<commit_message>
Add Report folder with project report and review presentation
</commit_message>
<xml_diff>
--- a/Week 5/24ADI204-Midreview.pptx
+++ b/Week 5/24ADI204-Midreview.pptx
@@ -12,7 +12,11 @@
     <p:sldId id="260" r:id="rId9"/>
     <p:sldId id="261" r:id="rId10"/>
     <p:sldId id="262" r:id="rId11"/>
+    <p:sldId id="270" r:id="rId28"/>
     <p:sldId id="263" r:id="rId12"/>
+    <p:sldId id="271" r:id="rId29"/>
+    <p:sldId id="272" r:id="rId30"/>
+    <p:sldId id="273" r:id="rId31"/>
     <p:sldId id="269" r:id="rId13"/>
     <p:sldId id="264" r:id="rId14"/>
     <p:sldId id="265" r:id="rId15"/>
@@ -4337,7 +4341,7 @@
                 <a:cs typeface="Poppins Italics" panose="00000500000000000000"/>
                 <a:sym typeface="Poppins Italics" panose="00000500000000000000"/>
               </a:rPr>
-              <a:t>Feature engineering: we will group the data by decade and region to prepare it for the final visualization.</a:t>
+              <a:t>Feature engineering: we will scale the numeric features and encode Country to prepare the data for PCA and the final visualization.</a:t>
             </a:r>
           </a:p>
           <a:p>
@@ -4983,6 +4987,127 @@
                   </a:ext>
                 </a:extLst>
               </a:tr>
+              <a:tr h="1046940">
+                <a:tc>
+                  <a:txBody>
+                    <a:bodyPr/>
+                    <a:lstStyle/>
+                    <a:p>
+                      <a:r>
+                        <a:rPr lang="en-IN" dirty="0"/>
+                        <a:t>Joyce Laetitia </a:t>
+                      </a:r>
+                      <a:r>
+                        <a:rPr lang="en-IN" dirty="0" err="1"/>
+                        <a:t>Malenou</a:t>
+                      </a:r>
+                      <a:r>
+                        <a:rPr lang="en-IN" dirty="0"/>
+                        <a:t> </a:t>
+                      </a:r>
+                      <a:r>
+                        <a:rPr lang="en-IN" dirty="0" err="1"/>
+                        <a:t>Weudji</a:t>
+                      </a:r>
+                      <a:endParaRPr dirty="0"/>
+                    </a:p>
+                  </a:txBody>
+                  <a:tcPr marL="190500" marR="190500" marT="190500" marB="190500" anchor="ctr">
+                    <a:lnL w="38100" cap="flat" cmpd="sng" algn="ctr">
+                      <a:solidFill>
+                        <a:srgbClr val="000000"/>
+                      </a:solidFill>
+                      <a:prstDash val="solid"/>
+                      <a:round/>
+                      <a:headEnd type="none" w="med" len="med"/>
+                      <a:tailEnd type="none" w="med" len="med"/>
+                    </a:lnL>
+                    <a:lnR w="38100" cap="flat" cmpd="sng" algn="ctr">
+                      <a:solidFill>
+                        <a:srgbClr val="000000"/>
+                      </a:solidFill>
+                      <a:prstDash val="solid"/>
+                      <a:round/>
+                      <a:headEnd type="none" w="med" len="med"/>
+                      <a:tailEnd type="none" w="med" len="med"/>
+                    </a:lnR>
+                    <a:lnT w="38100" cap="flat" cmpd="sng" algn="ctr">
+                      <a:solidFill>
+                        <a:srgbClr val="000000"/>
+                      </a:solidFill>
+                      <a:prstDash val="solid"/>
+                      <a:round/>
+                      <a:headEnd type="none" w="med" len="med"/>
+                      <a:tailEnd type="none" w="med" len="med"/>
+                    </a:lnT>
+                    <a:lnB w="38100" cap="flat" cmpd="sng" algn="ctr">
+                      <a:solidFill>
+                        <a:srgbClr val="000000"/>
+                      </a:solidFill>
+                      <a:prstDash val="solid"/>
+                      <a:round/>
+                      <a:headEnd type="none" w="med" len="med"/>
+                      <a:tailEnd type="none" w="med" len="med"/>
+                    </a:lnB>
+                  </a:tcPr>
+                </a:tc>
+                <a:tc>
+                  <a:txBody>
+                    <a:bodyPr/>
+                    <a:lstStyle/>
+                    <a:p>
+                      <a:r>
+                        <a:rPr lang="en-US" dirty="0"/>
+                        <a:t>Data Analyst &amp; Storyteller</a:t>
+                      </a:r>
+                      <a:endParaRPr dirty="0"/>
+                    </a:p>
+                  </a:txBody>
+                  <a:tcPr marL="190500" marR="190500" marT="190500" marB="190500" anchor="ctr">
+                    <a:lnL w="38100" cap="flat" cmpd="sng" algn="ctr">
+                      <a:solidFill>
+                        <a:srgbClr val="000000"/>
+                      </a:solidFill>
+                      <a:prstDash val="solid"/>
+                      <a:round/>
+                      <a:headEnd type="none" w="med" len="med"/>
+                      <a:tailEnd type="none" w="med" len="med"/>
+                    </a:lnL>
+                    <a:lnR w="38100" cap="flat" cmpd="sng" algn="ctr">
+                      <a:solidFill>
+                        <a:srgbClr val="000000"/>
+                      </a:solidFill>
+                      <a:prstDash val="solid"/>
+                      <a:round/>
+                      <a:headEnd type="none" w="med" len="med"/>
+                      <a:tailEnd type="none" w="med" len="med"/>
+                    </a:lnR>
+                    <a:lnT w="38100" cap="flat" cmpd="sng" algn="ctr">
+                      <a:solidFill>
+                        <a:srgbClr val="000000"/>
+                      </a:solidFill>
+                      <a:prstDash val="solid"/>
+                      <a:round/>
+                      <a:headEnd type="none" w="med" len="med"/>
+                      <a:tailEnd type="none" w="med" len="med"/>
+                    </a:lnT>
+                    <a:lnB w="38100" cap="flat" cmpd="sng" algn="ctr">
+                      <a:solidFill>
+                        <a:srgbClr val="000000"/>
+                      </a:solidFill>
+                      <a:prstDash val="solid"/>
+                      <a:round/>
+                      <a:headEnd type="none" w="med" len="med"/>
+                      <a:tailEnd type="none" w="med" len="med"/>
+                    </a:lnB>
+                  </a:tcPr>
+                </a:tc>
+                <a:extLst>
+                  <a:ext uri="{0D108BD9-81ED-4DB2-BD59-A6C34878D82A}">
+                    <a16:rowId xmlns:a16="http://schemas.microsoft.com/office/drawing/2014/main" val="10005"/>
+                  </a:ext>
+                </a:extLst>
+              </a:tr>
               <a:tr h="1002938">
                 <a:tc>
                   <a:txBody>
@@ -5201,127 +5326,6 @@
                   </a:ext>
                 </a:extLst>
               </a:tr>
-              <a:tr h="1046940">
-                <a:tc>
-                  <a:txBody>
-                    <a:bodyPr/>
-                    <a:lstStyle/>
-                    <a:p>
-                      <a:r>
-                        <a:rPr lang="en-IN" dirty="0"/>
-                        <a:t>Joyce Laetitia </a:t>
-                      </a:r>
-                      <a:r>
-                        <a:rPr lang="en-IN" dirty="0" err="1"/>
-                        <a:t>Malenou</a:t>
-                      </a:r>
-                      <a:r>
-                        <a:rPr lang="en-IN" dirty="0"/>
-                        <a:t> </a:t>
-                      </a:r>
-                      <a:r>
-                        <a:rPr lang="en-IN" dirty="0" err="1"/>
-                        <a:t>Weudji</a:t>
-                      </a:r>
-                      <a:endParaRPr dirty="0"/>
-                    </a:p>
-                  </a:txBody>
-                  <a:tcPr marL="190500" marR="190500" marT="190500" marB="190500" anchor="ctr">
-                    <a:lnL w="38100" cap="flat" cmpd="sng" algn="ctr">
-                      <a:solidFill>
-                        <a:srgbClr val="000000"/>
-                      </a:solidFill>
-                      <a:prstDash val="solid"/>
-                      <a:round/>
-                      <a:headEnd type="none" w="med" len="med"/>
-                      <a:tailEnd type="none" w="med" len="med"/>
-                    </a:lnL>
-                    <a:lnR w="38100" cap="flat" cmpd="sng" algn="ctr">
-                      <a:solidFill>
-                        <a:srgbClr val="000000"/>
-                      </a:solidFill>
-                      <a:prstDash val="solid"/>
-                      <a:round/>
-                      <a:headEnd type="none" w="med" len="med"/>
-                      <a:tailEnd type="none" w="med" len="med"/>
-                    </a:lnR>
-                    <a:lnT w="38100" cap="flat" cmpd="sng" algn="ctr">
-                      <a:solidFill>
-                        <a:srgbClr val="000000"/>
-                      </a:solidFill>
-                      <a:prstDash val="solid"/>
-                      <a:round/>
-                      <a:headEnd type="none" w="med" len="med"/>
-                      <a:tailEnd type="none" w="med" len="med"/>
-                    </a:lnT>
-                    <a:lnB w="38100" cap="flat" cmpd="sng" algn="ctr">
-                      <a:solidFill>
-                        <a:srgbClr val="000000"/>
-                      </a:solidFill>
-                      <a:prstDash val="solid"/>
-                      <a:round/>
-                      <a:headEnd type="none" w="med" len="med"/>
-                      <a:tailEnd type="none" w="med" len="med"/>
-                    </a:lnB>
-                  </a:tcPr>
-                </a:tc>
-                <a:tc>
-                  <a:txBody>
-                    <a:bodyPr/>
-                    <a:lstStyle/>
-                    <a:p>
-                      <a:r>
-                        <a:rPr lang="en-US" dirty="0"/>
-                        <a:t>Storyteller</a:t>
-                      </a:r>
-                      <a:endParaRPr dirty="0"/>
-                    </a:p>
-                  </a:txBody>
-                  <a:tcPr marL="190500" marR="190500" marT="190500" marB="190500" anchor="ctr">
-                    <a:lnL w="38100" cap="flat" cmpd="sng" algn="ctr">
-                      <a:solidFill>
-                        <a:srgbClr val="000000"/>
-                      </a:solidFill>
-                      <a:prstDash val="solid"/>
-                      <a:round/>
-                      <a:headEnd type="none" w="med" len="med"/>
-                      <a:tailEnd type="none" w="med" len="med"/>
-                    </a:lnL>
-                    <a:lnR w="38100" cap="flat" cmpd="sng" algn="ctr">
-                      <a:solidFill>
-                        <a:srgbClr val="000000"/>
-                      </a:solidFill>
-                      <a:prstDash val="solid"/>
-                      <a:round/>
-                      <a:headEnd type="none" w="med" len="med"/>
-                      <a:tailEnd type="none" w="med" len="med"/>
-                    </a:lnR>
-                    <a:lnT w="38100" cap="flat" cmpd="sng" algn="ctr">
-                      <a:solidFill>
-                        <a:srgbClr val="000000"/>
-                      </a:solidFill>
-                      <a:prstDash val="solid"/>
-                      <a:round/>
-                      <a:headEnd type="none" w="med" len="med"/>
-                      <a:tailEnd type="none" w="med" len="med"/>
-                    </a:lnT>
-                    <a:lnB w="38100" cap="flat" cmpd="sng" algn="ctr">
-                      <a:solidFill>
-                        <a:srgbClr val="000000"/>
-                      </a:solidFill>
-                      <a:prstDash val="solid"/>
-                      <a:round/>
-                      <a:headEnd type="none" w="med" len="med"/>
-                      <a:tailEnd type="none" w="med" len="med"/>
-                    </a:lnB>
-                  </a:tcPr>
-                </a:tc>
-                <a:extLst>
-                  <a:ext uri="{0D108BD9-81ED-4DB2-BD59-A6C34878D82A}">
-                    <a16:rowId xmlns:a16="http://schemas.microsoft.com/office/drawing/2014/main" val="10005"/>
-                  </a:ext>
-                </a:extLst>
-              </a:tr>
             </a:tbl>
           </a:graphicData>
         </a:graphic>
@@ -5779,7 +5783,7 @@
                 <a:cs typeface="Poppins Italics" panose="00000500000000000000"/>
                 <a:sym typeface="Poppins Italics" panose="00000500000000000000"/>
               </a:rPr>
-              <a:t>Several columns contained extreme outliers, so we used both the IQR and Z-score methods together to confirm which values were genuine extremes.</a:t>
+              <a:t>We expected extreme outliers, so we tested every numeric column with both the IQR and Z-score methods; neither method flagged any value.</a:t>
             </a:r>
           </a:p>
           <a:p>
@@ -6288,7 +6292,7 @@
                 </a:solidFill>
                 <a:latin typeface="Calibri" panose="020F0502020204030204"/>
               </a:rPr>
-              <a:t>Weeks 5 and 6 will focus on feature engineering (decade and region grouping) and building the final animated heatmap.</a:t>
+              <a:t>Weeks 5 and 6 will focus on feature engineering (scaling and encoding) and building the final animated heatmap.</a:t>
             </a:r>
           </a:p>
           <a:p>
@@ -6325,7 +6329,7 @@
                 </a:solidFill>
                 <a:latin typeface="Calibri" panose="020F0502020204030204"/>
               </a:rPr>
-              <a:t>Overall, the project has successfully cleaned and explored a 99,054-record climate dataset through Week 4, revealing meaningful variation in temperature anomalies across countries and decades, a solid, reliable foundation for the final visual story of global warming.</a:t>
+              <a:t>Overall, the project has successfully cleaned and explored a 100,000-record climate dataset through Week 4, giving a clear picture of how temperature anomalies are distributed across countries and decades, a solid, reliable foundation for the final visual story of global warming.</a:t>
             </a:r>
           </a:p>
         </p:txBody>
@@ -6451,7 +6455,7 @@
                 </a:solidFill>
                 <a:latin typeface="Calibri" panose="020F0502020204030204"/>
               </a:rPr>
-              <a:t>99,054</a:t>
+              <a:t>100,000</a:t>
             </a:r>
           </a:p>
           <a:p>
@@ -6808,7 +6812,7 @@
                 </a:solidFill>
                 <a:latin typeface="Calibri" panose="020F0502020204030204"/>
               </a:rPr>
-              <a:t>Global_Warming_Dataset.csv: course-provided dataset for 24ADI204 Data Science and Visualization</a:t>
+              <a:t>Global Warming Dataset: 195 Countries (1900-2023), Kaggle, by ankushpanday1</a:t>
             </a:r>
           </a:p>
           <a:p>
@@ -6917,7 +6921,7 @@
 </p:sld>
 </file>
 
-<file path=ppt/slides/slide2.xml><?xml version="1.0" encoding="utf-8"?>
+<file path=ppt/slides/slide15.xml><?xml version="1.0" encoding="utf-8"?>
 <p:sld xmlns:a="http://schemas.openxmlformats.org/drawingml/2006/main" xmlns:r="http://schemas.openxmlformats.org/officeDocument/2006/relationships" xmlns:p="http://schemas.openxmlformats.org/presentationml/2006/main">
   <p:cSld>
     <p:bg>
@@ -7047,7 +7051,7 @@
       </p:grpSp>
       <p:sp>
         <p:nvSpPr>
-          <p:cNvPr id="10" name="Rounded Rectangle 9"/>
+          <p:cNvPr id="9" name="Rounded Rectangle 8"/>
           <p:cNvSpPr/>
           <p:nvPr/>
         </p:nvSpPr>
@@ -7096,14 +7100,14 @@
       </p:sp>
       <p:sp>
         <p:nvSpPr>
-          <p:cNvPr id="5" name="TextBox 5"/>
+          <p:cNvPr id="7" name="TextBox 7"/>
           <p:cNvSpPr txBox="1"/>
           <p:nvPr/>
         </p:nvSpPr>
         <p:spPr>
           <a:xfrm>
-            <a:off x="4422448" y="923093"/>
-            <a:ext cx="8840169" cy="1185092"/>
+            <a:off x="1054565" y="985640"/>
+            <a:ext cx="16178870" cy="1069521"/>
           </a:xfrm>
           <a:prstGeom prst="rect">
             <a:avLst/>
@@ -7117,7 +7121,7 @@
           <a:p>
             <a:pPr algn="ctr">
               <a:lnSpc>
-                <a:spcPts val="9230"/>
+                <a:spcPts val="8250"/>
               </a:lnSpc>
               <a:spcBef>
                 <a:spcPct val="0"/>
@@ -7133,125 +7137,21 @@
                 <a:cs typeface="Poppins Bold" panose="00000800000000000000"/>
                 <a:sym typeface="Poppins Bold" panose="00000800000000000000"/>
               </a:rPr>
-              <a:t>Problem Statement </a:t>
-            </a:r>
-          </a:p>
-        </p:txBody>
-      </p:sp>
-      <p:sp>
-        <p:nvSpPr>
-          <p:cNvPr id="9" name="Oval 8"/>
-          <p:cNvSpPr/>
-          <p:nvPr/>
-        </p:nvSpPr>
-        <p:spPr>
-          <a:xfrm>
-            <a:off x="925233" y="4366971"/>
-            <a:ext cx="1524862" cy="1524862"/>
-          </a:xfrm>
-          <a:prstGeom prst="ellipse">
-            <a:avLst/>
-          </a:prstGeom>
-          <a:solidFill>
-            <a:srgbClr val="FCE7DC"/>
-          </a:solidFill>
-          <a:ln>
-            <a:noFill/>
-          </a:ln>
-          <a:effectLst/>
-        </p:spPr>
-        <p:style>
-          <a:lnRef idx="1">
-            <a:schemeClr val="accent1"/>
-          </a:lnRef>
-          <a:fillRef idx="3">
-            <a:schemeClr val="accent1"/>
-          </a:fillRef>
-          <a:effectRef idx="2">
-            <a:schemeClr val="accent1"/>
-          </a:effectRef>
-          <a:fontRef idx="minor">
-            <a:schemeClr val="lt1"/>
-          </a:fontRef>
-        </p:style>
-        <p:txBody>
-          <a:bodyPr rtlCol="0" anchor="ctr"/>
-          <a:lstStyle/>
-          <a:p>
-            <a:pPr algn="ctr"/>
-            <a:endParaRPr/>
-          </a:p>
-        </p:txBody>
-      </p:sp>
-      <p:sp>
-        <p:nvSpPr>
-          <p:cNvPr id="7" name="Freeform 7"/>
-          <p:cNvSpPr/>
-          <p:nvPr/>
-        </p:nvSpPr>
-        <p:spPr>
-          <a:xfrm>
-            <a:off x="734625" y="4263003"/>
-            <a:ext cx="1906078" cy="1732798"/>
-          </a:xfrm>
-          <a:custGeom>
-            <a:avLst/>
-            <a:gdLst/>
-            <a:ahLst/>
-            <a:cxnLst/>
-            <a:rect l="l" t="t" r="r" b="b"/>
-            <a:pathLst>
-              <a:path w="1906078" h="1732798">
-                <a:moveTo>
-                  <a:pt x="0" y="0"/>
-                </a:moveTo>
-                <a:lnTo>
-                  <a:pt x="1906078" y="0"/>
-                </a:lnTo>
-                <a:lnTo>
-                  <a:pt x="1906078" y="1732798"/>
-                </a:lnTo>
-                <a:lnTo>
-                  <a:pt x="0" y="1732798"/>
-                </a:lnTo>
-                <a:lnTo>
-                  <a:pt x="0" y="0"/>
-                </a:lnTo>
-                <a:close/>
-              </a:path>
-            </a:pathLst>
-          </a:custGeom>
-          <a:blipFill>
-            <a:blip>
-              <a:extLst>
-                <a:ext uri="{96DAC541-7B7A-43D3-8B79-37D633B846F1}">
-                  <asvg:svgBlip xmlns:asvg="http://schemas.microsoft.com/office/drawing/2016/SVG/main" r:embed="rId2"/>
-                </a:ext>
-              </a:extLst>
-            </a:blip>
-            <a:stretch>
-              <a:fillRect/>
-            </a:stretch>
-          </a:blipFill>
-        </p:spPr>
-        <p:txBody>
-          <a:bodyPr/>
-          <a:lstStyle/>
-          <a:p>
-            <a:endParaRPr lang="en-IN"/>
-          </a:p>
-        </p:txBody>
-      </p:sp>
-      <p:sp>
-        <p:nvSpPr>
-          <p:cNvPr id="8" name="TextBox 7"/>
+              <a:t>Outlier Check: Boxplots (Week 3)</a:t>
+            </a:r>
+          </a:p>
+        </p:txBody>
+      </p:sp>
+      <p:sp>
+        <p:nvSpPr>
+          <p:cNvPr id="10" name="TextBox 9"/>
           <p:cNvSpPr txBox="1"/>
           <p:nvPr/>
         </p:nvSpPr>
         <p:spPr>
           <a:xfrm>
-            <a:off x="2860631" y="4131254"/>
-            <a:ext cx="15200000" cy="2200000"/>
+            <a:off x="1200000" y="2900000"/>
+            <a:ext cx="15900000" cy="600000"/>
           </a:xfrm>
           <a:prstGeom prst="rect">
             <a:avLst/>
@@ -7264,290 +7164,42 @@
           </a:bodyPr>
           <a:lstStyle/>
           <a:p>
-            <a:pPr>
-              <a:lnSpc>
-                <a:spcPts val="4235"/>
-              </a:lnSpc>
-              <a:spcAft>
-                <a:spcPts val="1000"/>
-              </a:spcAft>
-            </a:pPr>
-            <a:r>
-              <a:rPr lang="en-US" sz="2600" b="1">
+            <a:r>
+              <a:rPr sz="2600" b="1">
                 <a:solidFill>
                   <a:srgbClr val="112D63"/>
                 </a:solidFill>
                 <a:latin typeface="Calibri" panose="020F0502020204030204"/>
               </a:rPr>
-              <a:t>Why this project matters:</a:t>
-            </a:r>
-          </a:p>
-          <a:p>
-            <a:pPr algn="l">
-              <a:lnSpc>
-                <a:spcPts val="4235"/>
-              </a:lnSpc>
-              <a:spcAft>
-                <a:spcPts val="1000"/>
-              </a:spcAft>
-              <a:buNone/>
-            </a:pPr>
-            <a:r>
-              <a:rPr sz="2500" b="0" i="0">
-                <a:solidFill>
-                  <a:srgbClr val="3F3F3F"/>
-                </a:solidFill>
-                <a:latin typeface="Calibri" panose="020F0502020204030204"/>
-              </a:rPr>
-              <a:t>Rising global temperatures are reshaping weather, sea levels and ecosystems, but the scale of this change is hard to grasp from raw numbers alone.</a:t>
-            </a:r>
-          </a:p>
-          <a:p>
-            <a:pPr algn="l">
-              <a:lnSpc>
-                <a:spcPts val="4235"/>
-              </a:lnSpc>
-              <a:spcAft>
-                <a:spcPts val="1000"/>
-              </a:spcAft>
-              <a:buNone/>
-            </a:pPr>
-            <a:endParaRPr sz="2500" b="0" i="0">
-              <a:solidFill>
-                <a:srgbClr val="3F3F3F"/>
-              </a:solidFill>
-              <a:latin typeface="Calibri" panose="020F0502020204030204"/>
-            </a:endParaRPr>
-          </a:p>
-          <a:p>
-            <a:pPr algn="l">
-              <a:lnSpc>
-                <a:spcPts val="4235"/>
-              </a:lnSpc>
-              <a:spcAft>
-                <a:spcPts val="1000"/>
-              </a:spcAft>
-              <a:buNone/>
-            </a:pPr>
-            <a:r>
-              <a:rPr sz="2500" b="0" i="0">
-                <a:solidFill>
-                  <a:srgbClr val="3F3F3F"/>
-                </a:solidFill>
-                <a:latin typeface="Calibri" panose="020F0502020204030204"/>
-              </a:rPr>
-              <a:t>This project uses 124 years of country-level climate data (1900-2023) to show, in a clear visual way, how much the planet has actually warmed and where that warming is happening fastest.</a:t>
-            </a:r>
-          </a:p>
-        </p:txBody>
-      </p:sp>
-      <p:sp>
-        <p:nvSpPr>
-          <p:cNvPr id="11" name="Rounded Rectangle 10"/>
-          <p:cNvSpPr/>
+              <a:t>No points fall outside the whiskers in any column, so no outliers were found.</a:t>
+            </a:r>
+          </a:p>
+        </p:txBody>
+      </p:sp>
+      <p:pic>
+        <p:nvPicPr>
+          <p:cNvPr id="11" name="Picture 10" descr="Boxplots of six numeric columns after cleaning"/>
+          <p:cNvPicPr>
+            <a:picLocks noChangeAspect="1"/>
+          </p:cNvPicPr>
           <p:nvPr/>
-        </p:nvSpPr>
+        </p:nvPicPr>
+        <p:blipFill>
+          <a:blip r:embed="rId2"/>
+          <a:stretch>
+            <a:fillRect/>
+          </a:stretch>
+        </p:blipFill>
         <p:spPr>
           <a:xfrm>
-            <a:off x="2860631" y="8000000"/>
-            <a:ext cx="4333333" cy="1300000"/>
-          </a:xfrm>
-          <a:prstGeom prst="roundRect">
-            <a:avLst>
-              <a:gd name="adj" fmla="val 8000"/>
-            </a:avLst>
+            <a:off x="4097090" y="3750000"/>
+            <a:ext cx="10093820" cy="5650000"/>
+          </a:xfrm>
+          <a:prstGeom prst="rect">
+            <a:avLst/>
           </a:prstGeom>
-          <a:solidFill>
-            <a:srgbClr val="F4F8FD"/>
-          </a:solidFill>
-          <a:ln w="12700">
-            <a:solidFill>
-              <a:srgbClr val="E1E8F2"/>
-            </a:solidFill>
-          </a:ln>
-          <a:effectLst/>
         </p:spPr>
-        <p:style>
-          <a:lnRef idx="1">
-            <a:schemeClr val="accent1"/>
-          </a:lnRef>
-          <a:fillRef idx="3">
-            <a:schemeClr val="accent1"/>
-          </a:fillRef>
-          <a:effectRef idx="2">
-            <a:schemeClr val="accent1"/>
-          </a:effectRef>
-          <a:fontRef idx="minor">
-            <a:schemeClr val="lt1"/>
-          </a:fontRef>
-        </p:style>
-        <p:txBody>
-          <a:bodyPr wrap="square" lIns="60000" tIns="120000" rIns="60000" rtlCol="0" anchor="ctr"/>
-          <a:lstStyle/>
-          <a:p>
-            <a:pPr algn="ctr"/>
-            <a:r>
-              <a:rPr sz="3000" b="1">
-                <a:solidFill>
-                  <a:srgbClr val="112D63"/>
-                </a:solidFill>
-                <a:latin typeface="Calibri" panose="020F0502020204030204"/>
-              </a:rPr>
-              <a:t>1900–2023</a:t>
-            </a:r>
-          </a:p>
-          <a:p>
-            <a:pPr algn="ctr"/>
-            <a:r>
-              <a:rPr sz="1400" b="0">
-                <a:solidFill>
-                  <a:srgbClr val="5A6472"/>
-                </a:solidFill>
-                <a:latin typeface="Calibri" panose="020F0502020204030204"/>
-              </a:rPr>
-              <a:t>Years of climate data</a:t>
-            </a:r>
-          </a:p>
-        </p:txBody>
-      </p:sp>
-      <p:sp>
-        <p:nvSpPr>
-          <p:cNvPr id="12" name="Rounded Rectangle 11"/>
-          <p:cNvSpPr/>
-          <p:nvPr/>
-        </p:nvSpPr>
-        <p:spPr>
-          <a:xfrm>
-            <a:off x="7443964" y="8000000"/>
-            <a:ext cx="4333333" cy="1300000"/>
-          </a:xfrm>
-          <a:prstGeom prst="roundRect">
-            <a:avLst>
-              <a:gd name="adj" fmla="val 8000"/>
-            </a:avLst>
-          </a:prstGeom>
-          <a:solidFill>
-            <a:srgbClr val="F4F8FD"/>
-          </a:solidFill>
-          <a:ln w="12700">
-            <a:solidFill>
-              <a:srgbClr val="E1E8F2"/>
-            </a:solidFill>
-          </a:ln>
-          <a:effectLst/>
-        </p:spPr>
-        <p:style>
-          <a:lnRef idx="1">
-            <a:schemeClr val="accent1"/>
-          </a:lnRef>
-          <a:fillRef idx="3">
-            <a:schemeClr val="accent1"/>
-          </a:fillRef>
-          <a:effectRef idx="2">
-            <a:schemeClr val="accent1"/>
-          </a:effectRef>
-          <a:fontRef idx="minor">
-            <a:schemeClr val="lt1"/>
-          </a:fontRef>
-        </p:style>
-        <p:txBody>
-          <a:bodyPr wrap="square" lIns="60000" tIns="120000" rIns="60000" rtlCol="0" anchor="ctr"/>
-          <a:lstStyle/>
-          <a:p>
-            <a:pPr algn="ctr"/>
-            <a:r>
-              <a:rPr sz="3000" b="1">
-                <a:solidFill>
-                  <a:srgbClr val="112D63"/>
-                </a:solidFill>
-                <a:latin typeface="Calibri" panose="020F0502020204030204"/>
-              </a:rPr>
-              <a:t>195</a:t>
-            </a:r>
-          </a:p>
-          <a:p>
-            <a:pPr algn="ctr"/>
-            <a:r>
-              <a:rPr sz="1400" b="0">
-                <a:solidFill>
-                  <a:srgbClr val="5A6472"/>
-                </a:solidFill>
-                <a:latin typeface="Calibri" panose="020F0502020204030204"/>
-              </a:rPr>
-              <a:t>Countries covered</a:t>
-            </a:r>
-          </a:p>
-        </p:txBody>
-      </p:sp>
-      <p:sp>
-        <p:nvSpPr>
-          <p:cNvPr id="13" name="Rounded Rectangle 12"/>
-          <p:cNvSpPr/>
-          <p:nvPr/>
-        </p:nvSpPr>
-        <p:spPr>
-          <a:xfrm>
-            <a:off x="12027297" y="8000000"/>
-            <a:ext cx="4333333" cy="1300000"/>
-          </a:xfrm>
-          <a:prstGeom prst="roundRect">
-            <a:avLst>
-              <a:gd name="adj" fmla="val 8000"/>
-            </a:avLst>
-          </a:prstGeom>
-          <a:solidFill>
-            <a:srgbClr val="F4F8FD"/>
-          </a:solidFill>
-          <a:ln w="12700">
-            <a:solidFill>
-              <a:srgbClr val="E1E8F2"/>
-            </a:solidFill>
-          </a:ln>
-          <a:effectLst/>
-        </p:spPr>
-        <p:style>
-          <a:lnRef idx="1">
-            <a:schemeClr val="accent1"/>
-          </a:lnRef>
-          <a:fillRef idx="3">
-            <a:schemeClr val="accent1"/>
-          </a:fillRef>
-          <a:effectRef idx="2">
-            <a:schemeClr val="accent1"/>
-          </a:effectRef>
-          <a:fontRef idx="minor">
-            <a:schemeClr val="lt1"/>
-          </a:fontRef>
-        </p:style>
-        <p:txBody>
-          <a:bodyPr wrap="square" lIns="60000" tIns="120000" rIns="60000" rtlCol="0" anchor="ctr"/>
-          <a:lstStyle/>
-          <a:p>
-            <a:pPr algn="ctr"/>
-            <a:r>
-              <a:rPr sz="3000" b="1">
-                <a:solidFill>
-                  <a:srgbClr val="112D63"/>
-                </a:solidFill>
-                <a:latin typeface="Calibri" panose="020F0502020204030204"/>
-              </a:rPr>
-              <a:t>100,000</a:t>
-            </a:r>
-          </a:p>
-          <a:p>
-            <a:pPr algn="ctr"/>
-            <a:r>
-              <a:rPr sz="1400" b="0">
-                <a:solidFill>
-                  <a:srgbClr val="5A6472"/>
-                </a:solidFill>
-                <a:latin typeface="Calibri" panose="020F0502020204030204"/>
-              </a:rPr>
-              <a:t>Records analyzed</a:t>
-            </a:r>
-          </a:p>
-        </p:txBody>
-      </p:sp>
+      </p:pic>
     </p:spTree>
   </p:cSld>
   <p:clrMapOvr>
@@ -7556,7 +7208,7 @@
 </p:sld>
 </file>
 
-<file path=ppt/slides/slide3.xml><?xml version="1.0" encoding="utf-8"?>
+<file path=ppt/slides/slide16.xml><?xml version="1.0" encoding="utf-8"?>
 <p:sld xmlns:a="http://schemas.openxmlformats.org/drawingml/2006/main" xmlns:r="http://schemas.openxmlformats.org/officeDocument/2006/relationships" xmlns:p="http://schemas.openxmlformats.org/presentationml/2006/main">
   <p:cSld>
     <p:bg>
@@ -7735,14 +7387,14 @@
       </p:sp>
       <p:sp>
         <p:nvSpPr>
-          <p:cNvPr id="5" name="TextBox 5"/>
+          <p:cNvPr id="7" name="TextBox 7"/>
           <p:cNvSpPr txBox="1"/>
           <p:nvPr/>
         </p:nvSpPr>
         <p:spPr>
           <a:xfrm>
-            <a:off x="4422448" y="923093"/>
-            <a:ext cx="8840169" cy="1185092"/>
+            <a:off x="1054565" y="985640"/>
+            <a:ext cx="16178870" cy="1069521"/>
           </a:xfrm>
           <a:prstGeom prst="rect">
             <a:avLst/>
@@ -7756,7 +7408,7 @@
           <a:p>
             <a:pPr algn="ctr">
               <a:lnSpc>
-                <a:spcPts val="9230"/>
+                <a:spcPts val="8250"/>
               </a:lnSpc>
               <a:spcBef>
                 <a:spcPct val="0"/>
@@ -7772,315 +7424,93 @@
                 <a:cs typeface="Poppins Bold" panose="00000800000000000000"/>
                 <a:sym typeface="Poppins Bold" panose="00000800000000000000"/>
               </a:rPr>
-              <a:t>Project Objectives</a:t>
-            </a:r>
-          </a:p>
-        </p:txBody>
-      </p:sp>
-      <p:sp>
-        <p:nvSpPr>
-          <p:cNvPr id="6" name="TextBox 6"/>
+              <a:t>EDA: Univariate Analysis (Week 4)</a:t>
+            </a:r>
+          </a:p>
+        </p:txBody>
+      </p:sp>
+      <p:sp>
+        <p:nvSpPr>
+          <p:cNvPr id="10" name="TextBox 9"/>
           <p:cNvSpPr txBox="1"/>
           <p:nvPr/>
         </p:nvSpPr>
         <p:spPr>
           <a:xfrm>
-            <a:off x="2860631" y="4607276"/>
-            <a:ext cx="15400000" cy="505523"/>
+            <a:off x="1200000" y="2900000"/>
+            <a:ext cx="15900000" cy="600000"/>
+          </a:xfrm>
+          <a:prstGeom prst="rect">
+            <a:avLst/>
+          </a:prstGeom>
+          <a:noFill/>
+        </p:spPr>
+        <p:txBody>
+          <a:bodyPr wrap="square">
+            <a:spAutoFit/>
+          </a:bodyPr>
+          <a:lstStyle/>
+          <a:p>
+            <a:r>
+              <a:rPr sz="2600" b="1">
+                <a:solidFill>
+                  <a:srgbClr val="112D63"/>
+                </a:solidFill>
+                <a:latin typeface="Calibri" panose="020F0502020204030204"/>
+              </a:rPr>
+              <a:t>Temperature anomalies are spread evenly from −2 to +2, in both periods.</a:t>
+            </a:r>
+          </a:p>
+        </p:txBody>
+      </p:sp>
+      <p:pic>
+        <p:nvPicPr>
+          <p:cNvPr id="11" name="Picture 10" descr="Histogram of temperature anomalies"/>
+          <p:cNvPicPr>
+            <a:picLocks noChangeAspect="1"/>
+          </p:cNvPicPr>
+          <p:nvPr/>
+        </p:nvPicPr>
+        <p:blipFill>
+          <a:blip r:embed="rId2"/>
+          <a:stretch>
+            <a:fillRect/>
+          </a:stretch>
+        </p:blipFill>
+        <p:spPr>
+          <a:xfrm>
+            <a:off x="500000" y="4263407"/>
+            <a:ext cx="8444000" cy="4623185"/>
           </a:xfrm>
           <a:prstGeom prst="rect">
             <a:avLst/>
           </a:prstGeom>
         </p:spPr>
-        <p:txBody>
-          <a:bodyPr wrap="square" lIns="0" tIns="0" rIns="0" bIns="0" rtlCol="0" anchor="t">
-            <a:spAutoFit/>
-          </a:bodyPr>
-          <a:lstStyle/>
-          <a:p>
-            <a:pPr marL="652780" lvl="1" indent="-326390" algn="l">
-              <a:lnSpc>
-                <a:spcPts val="4235"/>
-              </a:lnSpc>
-              <a:spcBef>
-                <a:spcPct val="0"/>
-              </a:spcBef>
-              <a:spcAft>
-                <a:spcPts val="1000"/>
-              </a:spcAft>
-              <a:buClr>
-                <a:srgbClr val="E8622C"/>
-              </a:buClr>
-              <a:buFont typeface="Arial" panose="020B0604020202020204"/>
-              <a:buChar char="•"/>
-            </a:pPr>
-            <a:r>
-              <a:rPr lang="en-US" sz="2500" b="0" i="0" dirty="0">
-                <a:solidFill>
-                  <a:srgbClr val="3F3F3F"/>
-                </a:solidFill>
-                <a:latin typeface="Calibri" panose="020F0502020204030204"/>
-                <a:ea typeface="Calibri" panose="020F0502020204030204"/>
-                <a:cs typeface="Calibri" panose="020F0502020204030204"/>
-              </a:rPr>
-              <a:t>We explore historical temperature anomaly data from 1900 to 2023 across 195 countries.</a:t>
-            </a:r>
-            <a:endParaRPr lang="en-US" sz="3000" dirty="0">
-              <a:solidFill>
-                <a:srgbClr val="545454"/>
-              </a:solidFill>
-              <a:ea typeface="Calibri" panose="020F0502020204030204"/>
-              <a:cs typeface="Calibri" panose="020F0502020204030204"/>
-            </a:endParaRPr>
-          </a:p>
-          <a:p>
-            <a:pPr marL="652780" lvl="1" indent="-326390" algn="l">
-              <a:lnSpc>
-                <a:spcPts val="4235"/>
-              </a:lnSpc>
-              <a:spcBef>
-                <a:spcPct val="0"/>
-              </a:spcBef>
-              <a:spcAft>
-                <a:spcPts val="1000"/>
-              </a:spcAft>
-              <a:buClr>
-                <a:srgbClr val="E8622C"/>
-              </a:buClr>
-              <a:buFont typeface="Arial" panose="020B0604020202020204"/>
-              <a:buChar char="•"/>
-            </a:pPr>
-            <a:r>
-              <a:rPr lang="en-US" sz="2500" b="0" i="0" dirty="0">
-                <a:solidFill>
-                  <a:srgbClr val="3F3F3F"/>
-                </a:solidFill>
-                <a:latin typeface="Calibri" panose="020F0502020204030204"/>
-                <a:ea typeface="Calibri" panose="020F0502020204030204"/>
-                <a:cs typeface="Calibri" panose="020F0502020204030204"/>
-              </a:rPr>
-              <a:t>We identify long-term warming trends and patterns across different regions and decades.</a:t>
-            </a:r>
-            <a:endParaRPr lang="en-US" sz="3000" dirty="0">
-              <a:solidFill>
-                <a:srgbClr val="545454"/>
-              </a:solidFill>
-              <a:ea typeface="Calibri" panose="020F0502020204030204"/>
-              <a:cs typeface="Calibri" panose="020F0502020204030204"/>
-            </a:endParaRPr>
-          </a:p>
-          <a:p>
-            <a:pPr marL="652780" lvl="1" indent="-326390" algn="l">
-              <a:lnSpc>
-                <a:spcPts val="4235"/>
-              </a:lnSpc>
-              <a:spcBef>
-                <a:spcPct val="0"/>
-              </a:spcBef>
-              <a:spcAft>
-                <a:spcPts val="1000"/>
-              </a:spcAft>
-              <a:buClr>
-                <a:srgbClr val="E8622C"/>
-              </a:buClr>
-              <a:buFont typeface="Arial" panose="020B0604020202020204"/>
-              <a:buChar char="•"/>
-            </a:pPr>
-            <a:r>
-              <a:rPr lang="en-US" sz="2500" b="0" i="0" dirty="0">
-                <a:solidFill>
-                  <a:srgbClr val="3F3F3F"/>
-                </a:solidFill>
-                <a:latin typeface="Calibri" panose="020F0502020204030204"/>
-                <a:ea typeface="Calibri" panose="020F0502020204030204"/>
-                <a:cs typeface="Calibri" panose="020F0502020204030204"/>
-              </a:rPr>
-              <a:t>We clean the dataset thoroughly, handling missing values and outliers so the analysis stays reliable.</a:t>
-            </a:r>
-            <a:endParaRPr lang="en-US" sz="3000" dirty="0">
-              <a:solidFill>
-                <a:srgbClr val="545454"/>
-              </a:solidFill>
-              <a:ea typeface="Calibri" panose="020F0502020204030204"/>
-              <a:cs typeface="Calibri" panose="020F0502020204030204"/>
-            </a:endParaRPr>
-          </a:p>
-          <a:p>
-            <a:pPr marL="652780" lvl="1" indent="-326390" algn="l">
-              <a:lnSpc>
-                <a:spcPts val="4235"/>
-              </a:lnSpc>
-              <a:spcBef>
-                <a:spcPct val="0"/>
-              </a:spcBef>
-              <a:spcAft>
-                <a:spcPts val="1000"/>
-              </a:spcAft>
-              <a:buClr>
-                <a:srgbClr val="E8622C"/>
-              </a:buClr>
-              <a:buFont typeface="Arial" panose="020B0604020202020204"/>
-              <a:buChar char="•"/>
-            </a:pPr>
-            <a:r>
-              <a:rPr lang="en-US" sz="2500" b="0" i="0" dirty="0">
-                <a:solidFill>
-                  <a:srgbClr val="3F3F3F"/>
-                </a:solidFill>
-                <a:latin typeface="Calibri" panose="020F0502020204030204"/>
-                <a:ea typeface="Calibri" panose="020F0502020204030204"/>
-                <a:cs typeface="Calibri" panose="020F0502020204030204"/>
-              </a:rPr>
-              <a:t>We aim to build a clear, animated "warming stripes" visualization that communicates climate change simply.</a:t>
-            </a:r>
-            <a:endParaRPr lang="en-US" sz="3000" dirty="0">
-              <a:solidFill>
-                <a:srgbClr val="545454"/>
-              </a:solidFill>
-              <a:ea typeface="Calibri" panose="020F0502020204030204"/>
-              <a:cs typeface="Calibri" panose="020F0502020204030204"/>
-            </a:endParaRPr>
-          </a:p>
-          <a:p>
-            <a:pPr marL="652780" lvl="1" indent="-326390" algn="l">
-              <a:lnSpc>
-                <a:spcPts val="4235"/>
-              </a:lnSpc>
-              <a:spcBef>
-                <a:spcPct val="0"/>
-              </a:spcBef>
-              <a:spcAft>
-                <a:spcPts val="1000"/>
-              </a:spcAft>
-              <a:buClr>
-                <a:srgbClr val="E8622C"/>
-              </a:buClr>
-              <a:buFont typeface="Arial" panose="020B0604020202020204"/>
-              <a:buChar char="•"/>
-            </a:pPr>
-            <a:r>
-              <a:rPr sz="2500" b="0" i="0">
-                <a:solidFill>
-                  <a:srgbClr val="3F3F3F"/>
-                </a:solidFill>
-                <a:latin typeface="Calibri" panose="020F0502020204030204"/>
-              </a:rPr>
-              <a:t>We document our process clearly each week so our GitHub repo tells the full story of the project.</a:t>
-            </a:r>
-            <a:endParaRPr lang="en-US" sz="3000" dirty="0">
-              <a:solidFill>
-                <a:srgbClr val="545454"/>
-              </a:solidFill>
-              <a:ea typeface="Calibri" panose="020F0502020204030204"/>
-              <a:cs typeface="Calibri" panose="020F0502020204030204"/>
-            </a:endParaRPr>
-          </a:p>
-        </p:txBody>
-      </p:sp>
-      <p:sp>
-        <p:nvSpPr>
-          <p:cNvPr id="8" name="Oval 7"/>
-          <p:cNvSpPr/>
+      </p:pic>
+      <p:pic>
+        <p:nvPicPr>
+          <p:cNvPr id="12" name="Picture 11" descr="Violin plot of temperature anomaly by period"/>
+          <p:cNvPicPr>
+            <a:picLocks noChangeAspect="1"/>
+          </p:cNvPicPr>
           <p:nvPr/>
-        </p:nvSpPr>
+        </p:nvPicPr>
+        <p:blipFill>
+          <a:blip r:embed="rId3"/>
+          <a:stretch>
+            <a:fillRect/>
+          </a:stretch>
+        </p:blipFill>
         <p:spPr>
           <a:xfrm>
-            <a:off x="901573" y="4198124"/>
-            <a:ext cx="1462556" cy="1462556"/>
-          </a:xfrm>
-          <a:prstGeom prst="ellipse">
+            <a:off x="9344000" y="3968561"/>
+            <a:ext cx="8444000" cy="5212877"/>
+          </a:xfrm>
+          <a:prstGeom prst="rect">
             <a:avLst/>
           </a:prstGeom>
-          <a:solidFill>
-            <a:srgbClr val="FCE7DC"/>
-          </a:solidFill>
-          <a:ln>
-            <a:noFill/>
-          </a:ln>
-          <a:effectLst/>
         </p:spPr>
-        <p:style>
-          <a:lnRef idx="1">
-            <a:schemeClr val="accent1"/>
-          </a:lnRef>
-          <a:fillRef idx="3">
-            <a:schemeClr val="accent1"/>
-          </a:fillRef>
-          <a:effectRef idx="2">
-            <a:schemeClr val="accent1"/>
-          </a:effectRef>
-          <a:fontRef idx="minor">
-            <a:schemeClr val="lt1"/>
-          </a:fontRef>
-        </p:style>
-        <p:txBody>
-          <a:bodyPr rtlCol="0" anchor="ctr"/>
-          <a:lstStyle/>
-          <a:p>
-            <a:pPr algn="ctr"/>
-            <a:endParaRPr/>
-          </a:p>
-        </p:txBody>
-      </p:sp>
-      <p:sp>
-        <p:nvSpPr>
-          <p:cNvPr id="7" name="Freeform 7"/>
-          <p:cNvSpPr/>
-          <p:nvPr/>
-        </p:nvSpPr>
-        <p:spPr>
-          <a:xfrm>
-            <a:off x="718753" y="4015304"/>
-            <a:ext cx="1828196" cy="1828196"/>
-          </a:xfrm>
-          <a:custGeom>
-            <a:avLst/>
-            <a:gdLst/>
-            <a:ahLst/>
-            <a:cxnLst/>
-            <a:rect l="l" t="t" r="r" b="b"/>
-            <a:pathLst>
-              <a:path w="1828196" h="1828196">
-                <a:moveTo>
-                  <a:pt x="0" y="0"/>
-                </a:moveTo>
-                <a:lnTo>
-                  <a:pt x="1828196" y="0"/>
-                </a:lnTo>
-                <a:lnTo>
-                  <a:pt x="1828196" y="1828196"/>
-                </a:lnTo>
-                <a:lnTo>
-                  <a:pt x="0" y="1828196"/>
-                </a:lnTo>
-                <a:lnTo>
-                  <a:pt x="0" y="0"/>
-                </a:lnTo>
-                <a:close/>
-              </a:path>
-            </a:pathLst>
-          </a:custGeom>
-          <a:blipFill>
-            <a:blip>
-              <a:extLst>
-                <a:ext uri="{96DAC541-7B7A-43D3-8B79-37D633B846F1}">
-                  <asvg:svgBlip xmlns:asvg="http://schemas.microsoft.com/office/drawing/2016/SVG/main" r:embed="rId2"/>
-                </a:ext>
-              </a:extLst>
-            </a:blip>
-            <a:stretch>
-              <a:fillRect/>
-            </a:stretch>
-          </a:blipFill>
-        </p:spPr>
-        <p:txBody>
-          <a:bodyPr/>
-          <a:lstStyle/>
-          <a:p>
-            <a:endParaRPr lang="en-IN"/>
-          </a:p>
-        </p:txBody>
-      </p:sp>
+      </p:pic>
     </p:spTree>
   </p:cSld>
   <p:clrMapOvr>
@@ -8089,7 +7519,7 @@
 </p:sld>
 </file>
 
-<file path=ppt/slides/slide4.xml><?xml version="1.0" encoding="utf-8"?>
+<file path=ppt/slides/slide17.xml><?xml version="1.0" encoding="utf-8"?>
 <p:sld xmlns:a="http://schemas.openxmlformats.org/drawingml/2006/main" xmlns:r="http://schemas.openxmlformats.org/officeDocument/2006/relationships" xmlns:p="http://schemas.openxmlformats.org/presentationml/2006/main">
   <p:cSld>
     <p:bg>
@@ -8219,7 +7649,7 @@
       </p:grpSp>
       <p:sp>
         <p:nvSpPr>
-          <p:cNvPr id="7" name="Rounded Rectangle 6"/>
+          <p:cNvPr id="9" name="Rounded Rectangle 8"/>
           <p:cNvSpPr/>
           <p:nvPr/>
         </p:nvSpPr>
@@ -8268,14 +7698,14 @@
       </p:sp>
       <p:sp>
         <p:nvSpPr>
-          <p:cNvPr id="5" name="TextBox 5"/>
+          <p:cNvPr id="7" name="TextBox 7"/>
           <p:cNvSpPr txBox="1"/>
           <p:nvPr/>
         </p:nvSpPr>
         <p:spPr>
           <a:xfrm>
-            <a:off x="4422448" y="923093"/>
-            <a:ext cx="8840169" cy="1185092"/>
+            <a:off x="1054565" y="985640"/>
+            <a:ext cx="16178870" cy="1069521"/>
           </a:xfrm>
           <a:prstGeom prst="rect">
             <a:avLst/>
@@ -8289,7 +7719,7 @@
           <a:p>
             <a:pPr algn="ctr">
               <a:lnSpc>
-                <a:spcPts val="9230"/>
+                <a:spcPts val="8250"/>
               </a:lnSpc>
               <a:spcBef>
                 <a:spcPct val="0"/>
@@ -8305,21 +7735,21 @@
                 <a:cs typeface="Poppins Bold" panose="00000800000000000000"/>
                 <a:sym typeface="Poppins Bold" panose="00000800000000000000"/>
               </a:rPr>
-              <a:t>Scope of the Project</a:t>
-            </a:r>
-          </a:p>
-        </p:txBody>
-      </p:sp>
-      <p:sp>
-        <p:nvSpPr>
-          <p:cNvPr id="6" name="TextBox 5"/>
+              <a:t>EDA: Trends Over Time (Week 4)</a:t>
+            </a:r>
+          </a:p>
+        </p:txBody>
+      </p:sp>
+      <p:sp>
+        <p:nvSpPr>
+          <p:cNvPr id="10" name="TextBox 9"/>
           <p:cNvSpPr txBox="1"/>
           <p:nvPr/>
         </p:nvSpPr>
         <p:spPr>
           <a:xfrm>
-            <a:off x="2860631" y="4000000"/>
-            <a:ext cx="15200000" cy="3500000"/>
+            <a:off x="1200000" y="2900000"/>
+            <a:ext cx="15900000" cy="600000"/>
           </a:xfrm>
           <a:prstGeom prst="rect">
             <a:avLst/>
@@ -8327,282 +7757,71 @@
           <a:noFill/>
         </p:spPr>
         <p:txBody>
-          <a:bodyPr rot="0" spcFirstLastPara="0" vertOverflow="overflow" horzOverflow="overflow" vert="horz" wrap="square" lIns="91440" tIns="45720" rIns="91440" bIns="45720" numCol="1" spcCol="0" rtlCol="0" fromWordArt="0" anchor="t" anchorCtr="0" forceAA="0" compatLnSpc="1">
+          <a:bodyPr wrap="square">
             <a:spAutoFit/>
           </a:bodyPr>
           <a:lstStyle/>
           <a:p>
-            <a:pPr>
-              <a:lnSpc>
-                <a:spcPts val="4235"/>
-              </a:lnSpc>
-              <a:spcAft>
-                <a:spcPts val="1000"/>
-              </a:spcAft>
-            </a:pPr>
-            <a:r>
-              <a:rPr lang="en-US" sz="2600" b="1">
+            <a:r>
+              <a:rPr sz="2600" b="1">
                 <a:solidFill>
                   <a:srgbClr val="112D63"/>
                 </a:solidFill>
                 <a:latin typeface="Calibri" panose="020F0502020204030204"/>
               </a:rPr>
-              <a:t>What's in scope, and what isn't:</a:t>
-            </a:r>
-          </a:p>
-          <a:p>
-            <a:pPr>
-              <a:spcAft>
-                <a:spcPts val="1000"/>
-              </a:spcAft>
-            </a:pPr>
-            <a:r>
-              <a:rPr lang="en-US" sz="2300" b="0" i="0">
-                <a:solidFill>
-                  <a:srgbClr val="3F3F3F"/>
-                </a:solidFill>
-                <a:latin typeface="Calibri" panose="020F0502020204030204"/>
-                <a:ea typeface="Calibri" panose="020F0502020204030204"/>
-                <a:cs typeface="Calibri" panose="020F0502020204030204"/>
-              </a:rPr>
-              <a:t>This project covers the Global Warming dataset (1900-2023): 100,000 records across 195 countries and 26 indicators, including temperature anomaly, CO2 emissions, population, forest area and renewable energy usage.</a:t>
-            </a:r>
-            <a:endParaRPr lang="en-US" sz="3000">
-              <a:ea typeface="Calibri" panose="020F0502020204030204"/>
-              <a:cs typeface="Calibri" panose="020F0502020204030204"/>
-            </a:endParaRPr>
-          </a:p>
-          <a:p>
-            <a:pPr>
-              <a:spcAft>
-                <a:spcPts val="1000"/>
-              </a:spcAft>
-            </a:pPr>
-            <a:r>
-              <a:rPr lang="en-US" sz="2300" b="0" i="0">
-                <a:solidFill>
-                  <a:srgbClr val="3F3F3F"/>
-                </a:solidFill>
-                <a:latin typeface="Calibri" panose="020F0502020204030204"/>
-                <a:ea typeface="Calibri" panose="020F0502020204030204"/>
-                <a:cs typeface="Calibri" panose="020F0502020204030204"/>
-              </a:rPr>
-              <a:t>The scope includes data cleaning, exploratory data analysis, and visualization, specifically building an animated heatmap of temperature anomalies over time. It does not include predictive modeling; the focus is on understanding and visually communicating what has already happened to the climate over the last century.</a:t>
-            </a:r>
-            <a:endParaRPr lang="en-US" sz="3000">
-              <a:ea typeface="Calibri" panose="020F0502020204030204"/>
-              <a:cs typeface="Calibri" panose="020F0502020204030204"/>
-            </a:endParaRPr>
-          </a:p>
-        </p:txBody>
-      </p:sp>
-      <p:sp>
-        <p:nvSpPr>
-          <p:cNvPr id="8" name="Rounded Rectangle 7"/>
-          <p:cNvSpPr/>
+              <a:t>The yearly mean anomaly stays within about ±0.1, with records spread evenly across decades.</a:t>
+            </a:r>
+          </a:p>
+        </p:txBody>
+      </p:sp>
+      <p:pic>
+        <p:nvPicPr>
+          <p:cNvPr id="11" name="Picture 10" descr="Line chart of mean temperature anomaly by year"/>
+          <p:cNvPicPr>
+            <a:picLocks noChangeAspect="1"/>
+          </p:cNvPicPr>
           <p:nvPr/>
-        </p:nvSpPr>
+        </p:nvPicPr>
+        <p:blipFill>
+          <a:blip r:embed="rId2"/>
+          <a:stretch>
+            <a:fillRect/>
+          </a:stretch>
+        </p:blipFill>
         <p:spPr>
           <a:xfrm>
-            <a:off x="2860631" y="6900000"/>
-            <a:ext cx="4333333" cy="1500000"/>
-          </a:xfrm>
-          <a:prstGeom prst="roundRect">
-            <a:avLst>
-              <a:gd name="adj" fmla="val 8000"/>
-            </a:avLst>
+            <a:off x="500000" y="4849115"/>
+            <a:ext cx="8444000" cy="3451770"/>
+          </a:xfrm>
+          <a:prstGeom prst="rect">
+            <a:avLst/>
           </a:prstGeom>
-          <a:solidFill>
-            <a:srgbClr val="F4F8FD"/>
-          </a:solidFill>
-          <a:ln w="12700">
-            <a:solidFill>
-              <a:srgbClr val="E1E8F2"/>
-            </a:solidFill>
-          </a:ln>
-          <a:effectLst/>
         </p:spPr>
-        <p:style>
-          <a:lnRef idx="1">
-            <a:schemeClr val="accent1"/>
-          </a:lnRef>
-          <a:fillRef idx="3">
-            <a:schemeClr val="accent1"/>
-          </a:fillRef>
-          <a:effectRef idx="2">
-            <a:schemeClr val="accent1"/>
-          </a:effectRef>
-          <a:fontRef idx="minor">
-            <a:schemeClr val="lt1"/>
-          </a:fontRef>
-        </p:style>
-        <p:txBody>
-          <a:bodyPr wrap="square" lIns="60000" tIns="120000" rIns="60000" rtlCol="0" anchor="ctr"/>
-          <a:lstStyle/>
-          <a:p>
-            <a:pPr algn="ctr"/>
-            <a:r>
-              <a:rPr sz="3000" b="1">
-                <a:solidFill>
-                  <a:srgbClr val="112D63"/>
-                </a:solidFill>
-                <a:latin typeface="Calibri" panose="020F0502020204030204"/>
-              </a:rPr>
-              <a:t>100,000</a:t>
-            </a:r>
-          </a:p>
-          <a:p>
-            <a:pPr algn="ctr"/>
-            <a:r>
-              <a:rPr sz="1400" b="0">
-                <a:solidFill>
-                  <a:srgbClr val="5A6472"/>
-                </a:solidFill>
-                <a:latin typeface="Calibri" panose="020F0502020204030204"/>
-              </a:rPr>
-              <a:t>Records</a:t>
-            </a:r>
-          </a:p>
-        </p:txBody>
-      </p:sp>
-      <p:sp>
-        <p:nvSpPr>
-          <p:cNvPr id="9" name="Rounded Rectangle 8"/>
-          <p:cNvSpPr/>
+      </p:pic>
+      <p:pic>
+        <p:nvPicPr>
+          <p:cNvPr id="12" name="Picture 11" descr="Bar chart of records per decade"/>
+          <p:cNvPicPr>
+            <a:picLocks noChangeAspect="1"/>
+          </p:cNvPicPr>
           <p:nvPr/>
-        </p:nvSpPr>
+        </p:nvPicPr>
+        <p:blipFill>
+          <a:blip r:embed="rId3"/>
+          <a:stretch>
+            <a:fillRect/>
+          </a:stretch>
+        </p:blipFill>
         <p:spPr>
           <a:xfrm>
-            <a:off x="7443964" y="6900000"/>
-            <a:ext cx="4333333" cy="1500000"/>
-          </a:xfrm>
-          <a:prstGeom prst="roundRect">
-            <a:avLst>
-              <a:gd name="adj" fmla="val 8000"/>
-            </a:avLst>
+            <a:off x="9344000" y="4849115"/>
+            <a:ext cx="8444000" cy="3451770"/>
+          </a:xfrm>
+          <a:prstGeom prst="rect">
+            <a:avLst/>
           </a:prstGeom>
-          <a:solidFill>
-            <a:srgbClr val="F4F8FD"/>
-          </a:solidFill>
-          <a:ln w="12700">
-            <a:solidFill>
-              <a:srgbClr val="E1E8F2"/>
-            </a:solidFill>
-          </a:ln>
-          <a:effectLst/>
         </p:spPr>
-        <p:style>
-          <a:lnRef idx="1">
-            <a:schemeClr val="accent1"/>
-          </a:lnRef>
-          <a:fillRef idx="3">
-            <a:schemeClr val="accent1"/>
-          </a:fillRef>
-          <a:effectRef idx="2">
-            <a:schemeClr val="accent1"/>
-          </a:effectRef>
-          <a:fontRef idx="minor">
-            <a:schemeClr val="lt1"/>
-          </a:fontRef>
-        </p:style>
-        <p:txBody>
-          <a:bodyPr wrap="square" lIns="60000" tIns="120000" rIns="60000" rtlCol="0" anchor="ctr"/>
-          <a:lstStyle/>
-          <a:p>
-            <a:pPr algn="ctr"/>
-            <a:r>
-              <a:rPr sz="3000" b="1">
-                <a:solidFill>
-                  <a:srgbClr val="112D63"/>
-                </a:solidFill>
-                <a:latin typeface="Calibri" panose="020F0502020204030204"/>
-              </a:rPr>
-              <a:t>195</a:t>
-            </a:r>
-          </a:p>
-          <a:p>
-            <a:pPr algn="ctr"/>
-            <a:r>
-              <a:rPr sz="1400" b="0">
-                <a:solidFill>
-                  <a:srgbClr val="5A6472"/>
-                </a:solidFill>
-                <a:latin typeface="Calibri" panose="020F0502020204030204"/>
-              </a:rPr>
-              <a:t>Countries</a:t>
-            </a:r>
-          </a:p>
-        </p:txBody>
-      </p:sp>
-      <p:sp>
-        <p:nvSpPr>
-          <p:cNvPr id="10" name="Rounded Rectangle 9"/>
-          <p:cNvSpPr/>
-          <p:nvPr/>
-        </p:nvSpPr>
-        <p:spPr>
-          <a:xfrm>
-            <a:off x="12027297" y="6900000"/>
-            <a:ext cx="4333333" cy="1500000"/>
-          </a:xfrm>
-          <a:prstGeom prst="roundRect">
-            <a:avLst>
-              <a:gd name="adj" fmla="val 8000"/>
-            </a:avLst>
-          </a:prstGeom>
-          <a:solidFill>
-            <a:srgbClr val="F4F8FD"/>
-          </a:solidFill>
-          <a:ln w="12700">
-            <a:solidFill>
-              <a:srgbClr val="E1E8F2"/>
-            </a:solidFill>
-          </a:ln>
-          <a:effectLst/>
-        </p:spPr>
-        <p:style>
-          <a:lnRef idx="1">
-            <a:schemeClr val="accent1"/>
-          </a:lnRef>
-          <a:fillRef idx="3">
-            <a:schemeClr val="accent1"/>
-          </a:fillRef>
-          <a:effectRef idx="2">
-            <a:schemeClr val="accent1"/>
-          </a:effectRef>
-          <a:fontRef idx="minor">
-            <a:schemeClr val="lt1"/>
-          </a:fontRef>
-        </p:style>
-        <p:txBody>
-          <a:bodyPr wrap="square" lIns="60000" tIns="120000" rIns="60000" rtlCol="0" anchor="ctr"/>
-          <a:lstStyle/>
-          <a:p>
-            <a:pPr algn="ctr"/>
-            <a:r>
-              <a:rPr sz="3000" b="1">
-                <a:solidFill>
-                  <a:srgbClr val="112D63"/>
-                </a:solidFill>
-                <a:latin typeface="Calibri" panose="020F0502020204030204"/>
-              </a:rPr>
-              <a:t>26</a:t>
-            </a:r>
-          </a:p>
-          <a:p>
-            <a:pPr algn="ctr"/>
-            <a:r>
-              <a:rPr sz="1400" b="0">
-                <a:solidFill>
-                  <a:srgbClr val="5A6472"/>
-                </a:solidFill>
-                <a:latin typeface="Calibri" panose="020F0502020204030204"/>
-              </a:rPr>
-              <a:t>Indicators tracked</a:t>
-            </a:r>
-          </a:p>
-        </p:txBody>
-      </p:sp>
+      </p:pic>
     </p:spTree>
   </p:cSld>
   <p:clrMapOvr>
@@ -8611,7 +7830,7 @@
 </p:sld>
 </file>
 
-<file path=ppt/slides/slide5.xml><?xml version="1.0" encoding="utf-8"?>
+<file path=ppt/slides/slide18.xml><?xml version="1.0" encoding="utf-8"?>
 <p:sld xmlns:a="http://schemas.openxmlformats.org/drawingml/2006/main" xmlns:r="http://schemas.openxmlformats.org/officeDocument/2006/relationships" xmlns:p="http://schemas.openxmlformats.org/presentationml/2006/main">
   <p:cSld>
     <p:bg>
@@ -8790,14 +8009,14 @@
       </p:sp>
       <p:sp>
         <p:nvSpPr>
-          <p:cNvPr id="5" name="TextBox 5"/>
+          <p:cNvPr id="7" name="TextBox 7"/>
           <p:cNvSpPr txBox="1"/>
           <p:nvPr/>
         </p:nvSpPr>
         <p:spPr>
           <a:xfrm>
-            <a:off x="4422448" y="923093"/>
-            <a:ext cx="8840169" cy="1185092"/>
+            <a:off x="1054565" y="985640"/>
+            <a:ext cx="16178870" cy="1069521"/>
           </a:xfrm>
           <a:prstGeom prst="rect">
             <a:avLst/>
@@ -8811,7 +8030,7 @@
           <a:p>
             <a:pPr algn="ctr">
               <a:lnSpc>
-                <a:spcPts val="9230"/>
+                <a:spcPts val="8250"/>
               </a:lnSpc>
               <a:spcBef>
                 <a:spcPct val="0"/>
@@ -8827,556 +8046,93 @@
                 <a:cs typeface="Poppins Bold" panose="00000800000000000000"/>
                 <a:sym typeface="Poppins Bold" panose="00000800000000000000"/>
               </a:rPr>
-              <a:t>Dataset Description</a:t>
-            </a:r>
-          </a:p>
-        </p:txBody>
-      </p:sp>
-      <p:sp>
-        <p:nvSpPr>
-          <p:cNvPr id="6" name="TextBox 6"/>
+              <a:t>EDA: Bivariate Analysis (Week 4)</a:t>
+            </a:r>
+          </a:p>
+        </p:txBody>
+      </p:sp>
+      <p:sp>
+        <p:nvSpPr>
+          <p:cNvPr id="10" name="TextBox 9"/>
           <p:cNvSpPr txBox="1"/>
           <p:nvPr/>
         </p:nvSpPr>
         <p:spPr>
           <a:xfrm>
-            <a:off x="2406709" y="3231254"/>
-            <a:ext cx="15200000" cy="3744230"/>
+            <a:off x="1200000" y="2900000"/>
+            <a:ext cx="15900000" cy="600000"/>
           </a:xfrm>
           <a:prstGeom prst="rect">
             <a:avLst/>
           </a:prstGeom>
+          <a:noFill/>
         </p:spPr>
         <p:txBody>
-          <a:bodyPr lIns="0" tIns="0" rIns="0" bIns="0" rtlCol="0" anchor="t">
+          <a:bodyPr wrap="square">
             <a:spAutoFit/>
           </a:bodyPr>
           <a:lstStyle/>
           <a:p>
-            <a:pPr>
-              <a:lnSpc>
-                <a:spcPts val="4235"/>
-              </a:lnSpc>
-              <a:spcAft>
-                <a:spcPts val="1000"/>
-              </a:spcAft>
-            </a:pPr>
-            <a:r>
-              <a:rPr lang="en-US" sz="2600" b="1" i="0">
-                <a:solidFill>
-                  <a:srgbClr val="112D63"/>
-                </a:solidFill>
-                <a:latin typeface="Calibri" panose="020F0502020204030204"/>
-                <a:ea typeface="+mn-lt"/>
-                <a:cs typeface="Poppins Italics" panose="00000500000000000000"/>
-              </a:rPr>
-              <a:t>Here are the key details of our dataset:</a:t>
-            </a:r>
-            <a:endParaRPr lang="en-US"/>
-          </a:p>
-          <a:p>
-            <a:pPr marL="652780" lvl="1" indent="-326390">
-              <a:lnSpc>
-                <a:spcPts val="4235"/>
-              </a:lnSpc>
-              <a:spcAft>
-                <a:spcPts val="1000"/>
-              </a:spcAft>
-              <a:buClr>
-                <a:srgbClr val="E8622C"/>
-              </a:buClr>
-              <a:buFont typeface="Arial" panose="020B0604020202020204"/>
-              <a:buChar char="•"/>
-            </a:pPr>
-            <a:r>
-              <a:rPr lang="en-US" sz="2200" b="0" i="0">
-                <a:solidFill>
-                  <a:srgbClr val="3F3F3F"/>
-                </a:solidFill>
-                <a:latin typeface="Calibri" panose="020F0502020204030204"/>
-                <a:ea typeface="+mn-lt"/>
-                <a:cs typeface="Poppins Italics" panose="00000500000000000000"/>
-                <a:sym typeface="Poppins Italics" panose="00000500000000000000"/>
-              </a:rPr>
-              <a:t>The dataset comes from a structured CSV file provided for the course, called Global_Warming_Dataset.csv.</a:t>
-            </a:r>
-            <a:endParaRPr lang="en-US" sz="3000" i="1">
-              <a:solidFill>
-                <a:srgbClr val="545454"/>
-              </a:solidFill>
-              <a:latin typeface="Poppins Italics" panose="00000500000000000000"/>
-              <a:ea typeface="Calibri" panose="020F0502020204030204"/>
-              <a:cs typeface="Poppins Italics" panose="00000500000000000000"/>
-            </a:endParaRPr>
-          </a:p>
-          <a:p>
-            <a:pPr marL="652780" lvl="1" indent="-326390">
-              <a:lnSpc>
-                <a:spcPts val="4235"/>
-              </a:lnSpc>
-              <a:spcAft>
-                <a:spcPts val="1000"/>
-              </a:spcAft>
-              <a:buClr>
-                <a:srgbClr val="E8622C"/>
-              </a:buClr>
-              <a:buFont typeface="Arial" panose="020B0604020202020204"/>
-              <a:buChar char="•"/>
-            </a:pPr>
-            <a:r>
-              <a:rPr lang="en-US" sz="2200" b="0" i="0">
-                <a:solidFill>
-                  <a:srgbClr val="3F3F3F"/>
-                </a:solidFill>
-                <a:latin typeface="Calibri" panose="020F0502020204030204"/>
-                <a:ea typeface="+mn-lt"/>
-                <a:cs typeface="Poppins Italics" panose="00000500000000000000"/>
-                <a:sym typeface="Poppins Italics" panose="00000500000000000000"/>
-              </a:rPr>
-              <a:t>The variable we study most closely throughout the project is Temperature_Anomaly.</a:t>
-            </a:r>
-            <a:endParaRPr lang="en-US" sz="3000" i="1">
-              <a:solidFill>
-                <a:srgbClr val="545454"/>
-              </a:solidFill>
-              <a:latin typeface="Poppins Italics" panose="00000500000000000000"/>
-              <a:ea typeface="+mn-lt"/>
-              <a:cs typeface="Poppins Italics" panose="00000500000000000000"/>
-            </a:endParaRPr>
-          </a:p>
-          <a:p>
-            <a:pPr marL="652780" lvl="1" indent="-326390">
-              <a:lnSpc>
-                <a:spcPts val="4235"/>
-              </a:lnSpc>
-              <a:spcAft>
-                <a:spcPts val="1000"/>
-              </a:spcAft>
-              <a:buClr>
-                <a:srgbClr val="E8622C"/>
-              </a:buClr>
-              <a:buFont typeface="Arial" panose="020B0604020202020204"/>
-              <a:buChar char="•"/>
-            </a:pPr>
-            <a:r>
-              <a:rPr sz="2200" b="0" i="0">
-                <a:solidFill>
-                  <a:srgbClr val="3F3F3F"/>
-                </a:solidFill>
-                <a:latin typeface="Calibri" panose="020F0502020204030204"/>
-              </a:rPr>
-              <a:t>The data is structured and almost entirely numeric, with Country as the only categorical field.</a:t>
-            </a:r>
-            <a:endParaRPr lang="en-US" sz="3000" i="1">
-              <a:solidFill>
-                <a:srgbClr val="545454"/>
-              </a:solidFill>
-              <a:latin typeface="Poppins Italics" panose="00000500000000000000"/>
-              <a:ea typeface="+mn-lt"/>
-              <a:cs typeface="Poppins Italics" panose="00000500000000000000"/>
-            </a:endParaRPr>
-          </a:p>
-          <a:p>
-            <a:pPr algn="l">
-              <a:lnSpc>
-                <a:spcPts val="4235"/>
-              </a:lnSpc>
-              <a:spcAft>
-                <a:spcPts val="1000"/>
-              </a:spcAft>
-            </a:pPr>
-            <a:endParaRPr lang="en-US" sz="3025" i="1">
-              <a:solidFill>
-                <a:srgbClr val="545454"/>
-              </a:solidFill>
-              <a:latin typeface="Poppins Italics" panose="00000500000000000000"/>
-              <a:ea typeface="Poppins Italics" panose="00000500000000000000"/>
-              <a:cs typeface="Poppins Italics" panose="00000500000000000000"/>
-              <a:sym typeface="Poppins Italics" panose="00000500000000000000"/>
-            </a:endParaRPr>
-          </a:p>
-        </p:txBody>
-      </p:sp>
-      <p:sp>
-        <p:nvSpPr>
-          <p:cNvPr id="8" name="Oval 7"/>
-          <p:cNvSpPr/>
-          <p:nvPr/>
-        </p:nvSpPr>
-        <p:spPr>
-          <a:xfrm>
-            <a:off x="745662" y="3482682"/>
-            <a:ext cx="1249424" cy="1249424"/>
-          </a:xfrm>
-          <a:prstGeom prst="ellipse">
-            <a:avLst/>
-          </a:prstGeom>
-          <a:solidFill>
-            <a:srgbClr val="FCE7DC"/>
-          </a:solidFill>
-          <a:ln>
-            <a:noFill/>
-          </a:ln>
-          <a:effectLst/>
-        </p:spPr>
-        <p:style>
-          <a:lnRef idx="1">
-            <a:schemeClr val="accent1"/>
-          </a:lnRef>
-          <a:fillRef idx="3">
-            <a:schemeClr val="accent1"/>
-          </a:fillRef>
-          <a:effectRef idx="2">
-            <a:schemeClr val="accent1"/>
-          </a:effectRef>
-          <a:fontRef idx="minor">
-            <a:schemeClr val="lt1"/>
-          </a:fontRef>
-        </p:style>
-        <p:txBody>
-          <a:bodyPr rtlCol="0" anchor="ctr"/>
-          <a:lstStyle/>
-          <a:p>
-            <a:pPr algn="ctr"/>
-            <a:endParaRPr/>
-          </a:p>
-        </p:txBody>
-      </p:sp>
-      <p:sp>
-        <p:nvSpPr>
-          <p:cNvPr id="7" name="Freeform 7"/>
-          <p:cNvSpPr/>
-          <p:nvPr/>
-        </p:nvSpPr>
-        <p:spPr>
-          <a:xfrm>
-            <a:off x="589484" y="3326504"/>
-            <a:ext cx="1561780" cy="1561780"/>
-          </a:xfrm>
-          <a:custGeom>
-            <a:avLst/>
-            <a:gdLst/>
-            <a:ahLst/>
-            <a:cxnLst/>
-            <a:rect l="l" t="t" r="r" b="b"/>
-            <a:pathLst>
-              <a:path w="1561780" h="1561780">
-                <a:moveTo>
-                  <a:pt x="0" y="0"/>
-                </a:moveTo>
-                <a:lnTo>
-                  <a:pt x="1561781" y="0"/>
-                </a:lnTo>
-                <a:lnTo>
-                  <a:pt x="1561781" y="1561780"/>
-                </a:lnTo>
-                <a:lnTo>
-                  <a:pt x="0" y="1561780"/>
-                </a:lnTo>
-                <a:lnTo>
-                  <a:pt x="0" y="0"/>
-                </a:lnTo>
-                <a:close/>
-              </a:path>
-            </a:pathLst>
-          </a:custGeom>
-          <a:blipFill>
-            <a:blip>
-              <a:extLst>
-                <a:ext uri="{96DAC541-7B7A-43D3-8B79-37D633B846F1}">
-                  <asvg:svgBlip xmlns:asvg="http://schemas.microsoft.com/office/drawing/2016/SVG/main" r:embed="rId2"/>
-                </a:ext>
-              </a:extLst>
-            </a:blip>
-            <a:stretch>
-              <a:fillRect/>
-            </a:stretch>
-          </a:blipFill>
-        </p:spPr>
-        <p:txBody>
-          <a:bodyPr/>
-          <a:lstStyle/>
-          <a:p>
-            <a:endParaRPr lang="en-IN"/>
-          </a:p>
-        </p:txBody>
-      </p:sp>
-      <p:sp>
-        <p:nvSpPr>
-          <p:cNvPr id="10" name="Rounded Rectangle 9"/>
-          <p:cNvSpPr/>
-          <p:nvPr/>
-        </p:nvSpPr>
-        <p:spPr>
-          <a:xfrm>
-            <a:off x="2406709" y="6750000"/>
-            <a:ext cx="3612500" cy="1500000"/>
-          </a:xfrm>
-          <a:prstGeom prst="roundRect">
-            <a:avLst>
-              <a:gd name="adj" fmla="val 8000"/>
-            </a:avLst>
-          </a:prstGeom>
-          <a:solidFill>
-            <a:srgbClr val="F4F8FD"/>
-          </a:solidFill>
-          <a:ln w="12700">
-            <a:solidFill>
-              <a:srgbClr val="E1E8F2"/>
-            </a:solidFill>
-          </a:ln>
-          <a:effectLst/>
-        </p:spPr>
-        <p:style>
-          <a:lnRef idx="1">
-            <a:schemeClr val="accent1"/>
-          </a:lnRef>
-          <a:fillRef idx="3">
-            <a:schemeClr val="accent1"/>
-          </a:fillRef>
-          <a:effectRef idx="2">
-            <a:schemeClr val="accent1"/>
-          </a:effectRef>
-          <a:fontRef idx="minor">
-            <a:schemeClr val="lt1"/>
-          </a:fontRef>
-        </p:style>
-        <p:txBody>
-          <a:bodyPr wrap="square" lIns="60000" tIns="120000" rIns="60000" rtlCol="0" anchor="ctr"/>
-          <a:lstStyle/>
-          <a:p>
-            <a:pPr algn="ctr"/>
-            <a:r>
-              <a:rPr sz="3000" b="1">
+            <a:r>
+              <a:rPr sz="2600" b="1">
                 <a:solidFill>
                   <a:srgbClr val="112D63"/>
                 </a:solidFill>
                 <a:latin typeface="Calibri" panose="020F0502020204030204"/>
               </a:rPr>
-              <a:t>100,000</a:t>
-            </a:r>
-          </a:p>
-          <a:p>
-            <a:pPr algn="ctr"/>
-            <a:r>
-              <a:rPr sz="1400" b="0">
-                <a:solidFill>
-                  <a:srgbClr val="5A6472"/>
-                </a:solidFill>
-                <a:latin typeface="Calibri" panose="020F0502020204030204"/>
-              </a:rPr>
-              <a:t>Records</a:t>
-            </a:r>
-          </a:p>
-        </p:txBody>
-      </p:sp>
-      <p:sp>
-        <p:nvSpPr>
-          <p:cNvPr id="11" name="Rounded Rectangle 10"/>
-          <p:cNvSpPr/>
+              <a:t>Deforestation rate and biodiversity show no relationship; all correlations are close to zero.</a:t>
+            </a:r>
+          </a:p>
+        </p:txBody>
+      </p:sp>
+      <p:pic>
+        <p:nvPicPr>
+          <p:cNvPr id="11" name="Picture 10" descr="Regression plot of deforestation rate against biodiversity index"/>
+          <p:cNvPicPr>
+            <a:picLocks noChangeAspect="1"/>
+          </p:cNvPicPr>
           <p:nvPr/>
-        </p:nvSpPr>
+        </p:nvPicPr>
+        <p:blipFill>
+          <a:blip r:embed="rId2"/>
+          <a:stretch>
+            <a:fillRect/>
+          </a:stretch>
+        </p:blipFill>
         <p:spPr>
           <a:xfrm>
-            <a:off x="6269209" y="6750000"/>
-            <a:ext cx="3612500" cy="1500000"/>
-          </a:xfrm>
-          <a:prstGeom prst="roundRect">
-            <a:avLst>
-              <a:gd name="adj" fmla="val 8000"/>
-            </a:avLst>
+            <a:off x="500000" y="4069260"/>
+            <a:ext cx="8444000" cy="5011479"/>
+          </a:xfrm>
+          <a:prstGeom prst="rect">
+            <a:avLst/>
           </a:prstGeom>
-          <a:solidFill>
-            <a:srgbClr val="F4F8FD"/>
-          </a:solidFill>
-          <a:ln w="12700">
-            <a:solidFill>
-              <a:srgbClr val="E1E8F2"/>
-            </a:solidFill>
-          </a:ln>
-          <a:effectLst/>
         </p:spPr>
-        <p:style>
-          <a:lnRef idx="1">
-            <a:schemeClr val="accent1"/>
-          </a:lnRef>
-          <a:fillRef idx="3">
-            <a:schemeClr val="accent1"/>
-          </a:fillRef>
-          <a:effectRef idx="2">
-            <a:schemeClr val="accent1"/>
-          </a:effectRef>
-          <a:fontRef idx="minor">
-            <a:schemeClr val="lt1"/>
-          </a:fontRef>
-        </p:style>
-        <p:txBody>
-          <a:bodyPr wrap="square" lIns="60000" tIns="120000" rIns="60000" rtlCol="0" anchor="ctr"/>
-          <a:lstStyle/>
-          <a:p>
-            <a:pPr algn="ctr"/>
-            <a:r>
-              <a:rPr sz="3000" b="1">
-                <a:solidFill>
-                  <a:srgbClr val="112D63"/>
-                </a:solidFill>
-                <a:latin typeface="Calibri" panose="020F0502020204030204"/>
-              </a:rPr>
-              <a:t>195</a:t>
-            </a:r>
-          </a:p>
-          <a:p>
-            <a:pPr algn="ctr"/>
-            <a:r>
-              <a:rPr sz="1400" b="0">
-                <a:solidFill>
-                  <a:srgbClr val="5A6472"/>
-                </a:solidFill>
-                <a:latin typeface="Calibri" panose="020F0502020204030204"/>
-              </a:rPr>
-              <a:t>Countries</a:t>
-            </a:r>
-          </a:p>
-        </p:txBody>
-      </p:sp>
-      <p:sp>
-        <p:nvSpPr>
-          <p:cNvPr id="12" name="Rounded Rectangle 11"/>
-          <p:cNvSpPr/>
+      </p:pic>
+      <p:pic>
+        <p:nvPicPr>
+          <p:cNvPr id="12" name="Picture 11" descr="Correlation heatmap of eight climate variables"/>
+          <p:cNvPicPr>
+            <a:picLocks noChangeAspect="1"/>
+          </p:cNvPicPr>
           <p:nvPr/>
-        </p:nvSpPr>
+        </p:nvPicPr>
+        <p:blipFill>
+          <a:blip r:embed="rId3"/>
+          <a:stretch>
+            <a:fillRect/>
+          </a:stretch>
+        </p:blipFill>
         <p:spPr>
           <a:xfrm>
-            <a:off x="10131709" y="6750000"/>
-            <a:ext cx="3612500" cy="1500000"/>
-          </a:xfrm>
-          <a:prstGeom prst="roundRect">
-            <a:avLst>
-              <a:gd name="adj" fmla="val 8000"/>
-            </a:avLst>
+            <a:off x="9737382" y="3750000"/>
+            <a:ext cx="7657236" cy="5650000"/>
+          </a:xfrm>
+          <a:prstGeom prst="rect">
+            <a:avLst/>
           </a:prstGeom>
-          <a:solidFill>
-            <a:srgbClr val="F4F8FD"/>
-          </a:solidFill>
-          <a:ln w="12700">
-            <a:solidFill>
-              <a:srgbClr val="E1E8F2"/>
-            </a:solidFill>
-          </a:ln>
-          <a:effectLst/>
         </p:spPr>
-        <p:style>
-          <a:lnRef idx="1">
-            <a:schemeClr val="accent1"/>
-          </a:lnRef>
-          <a:fillRef idx="3">
-            <a:schemeClr val="accent1"/>
-          </a:fillRef>
-          <a:effectRef idx="2">
-            <a:schemeClr val="accent1"/>
-          </a:effectRef>
-          <a:fontRef idx="minor">
-            <a:schemeClr val="lt1"/>
-          </a:fontRef>
-        </p:style>
-        <p:txBody>
-          <a:bodyPr wrap="square" lIns="60000" tIns="120000" rIns="60000" rtlCol="0" anchor="ctr"/>
-          <a:lstStyle/>
-          <a:p>
-            <a:pPr algn="ctr"/>
-            <a:r>
-              <a:rPr sz="3000" b="1">
-                <a:solidFill>
-                  <a:srgbClr val="112D63"/>
-                </a:solidFill>
-                <a:latin typeface="Calibri" panose="020F0502020204030204"/>
-              </a:rPr>
-              <a:t>26</a:t>
-            </a:r>
-          </a:p>
-          <a:p>
-            <a:pPr algn="ctr"/>
-            <a:r>
-              <a:rPr sz="1400" b="0">
-                <a:solidFill>
-                  <a:srgbClr val="5A6472"/>
-                </a:solidFill>
-                <a:latin typeface="Calibri" panose="020F0502020204030204"/>
-              </a:rPr>
-              <a:t>Columns</a:t>
-            </a:r>
-          </a:p>
-        </p:txBody>
-      </p:sp>
-      <p:sp>
-        <p:nvSpPr>
-          <p:cNvPr id="13" name="Rounded Rectangle 12"/>
-          <p:cNvSpPr/>
-          <p:nvPr/>
-        </p:nvSpPr>
-        <p:spPr>
-          <a:xfrm>
-            <a:off x="13994209" y="6750000"/>
-            <a:ext cx="3612500" cy="1500000"/>
-          </a:xfrm>
-          <a:prstGeom prst="roundRect">
-            <a:avLst>
-              <a:gd name="adj" fmla="val 8000"/>
-            </a:avLst>
-          </a:prstGeom>
-          <a:solidFill>
-            <a:srgbClr val="F4F8FD"/>
-          </a:solidFill>
-          <a:ln w="12700">
-            <a:solidFill>
-              <a:srgbClr val="E1E8F2"/>
-            </a:solidFill>
-          </a:ln>
-          <a:effectLst/>
-        </p:spPr>
-        <p:style>
-          <a:lnRef idx="1">
-            <a:schemeClr val="accent1"/>
-          </a:lnRef>
-          <a:fillRef idx="3">
-            <a:schemeClr val="accent1"/>
-          </a:fillRef>
-          <a:effectRef idx="2">
-            <a:schemeClr val="accent1"/>
-          </a:effectRef>
-          <a:fontRef idx="minor">
-            <a:schemeClr val="lt1"/>
-          </a:fontRef>
-        </p:style>
-        <p:txBody>
-          <a:bodyPr wrap="square" lIns="60000" tIns="120000" rIns="60000" rtlCol="0" anchor="ctr"/>
-          <a:lstStyle/>
-          <a:p>
-            <a:pPr algn="ctr"/>
-            <a:r>
-              <a:rPr sz="3000" b="1">
-                <a:solidFill>
-                  <a:srgbClr val="112D63"/>
-                </a:solidFill>
-                <a:latin typeface="Calibri" panose="020F0502020204030204"/>
-              </a:rPr>
-              <a:t>1900–2023</a:t>
-            </a:r>
-          </a:p>
-          <a:p>
-            <a:pPr algn="ctr"/>
-            <a:r>
-              <a:rPr sz="1400" b="0">
-                <a:solidFill>
-                  <a:srgbClr val="5A6472"/>
-                </a:solidFill>
-                <a:latin typeface="Calibri" panose="020F0502020204030204"/>
-              </a:rPr>
-              <a:t>Years covered</a:t>
-            </a:r>
-          </a:p>
-        </p:txBody>
-      </p:sp>
+      </p:pic>
     </p:spTree>
   </p:cSld>
   <p:clrMapOvr>
@@ -9385,7 +8141,7 @@
 </p:sld>
 </file>
 
-<file path=ppt/slides/slide6.xml><?xml version="1.0" encoding="utf-8"?>
+<file path=ppt/slides/slide2.xml><?xml version="1.0" encoding="utf-8"?>
 <p:sld xmlns:a="http://schemas.openxmlformats.org/drawingml/2006/main" xmlns:r="http://schemas.openxmlformats.org/officeDocument/2006/relationships" xmlns:p="http://schemas.openxmlformats.org/presentationml/2006/main">
   <p:cSld>
     <p:bg>
@@ -9515,7 +8271,7 @@
       </p:grpSp>
       <p:sp>
         <p:nvSpPr>
-          <p:cNvPr id="9" name="Rounded Rectangle 8"/>
+          <p:cNvPr id="10" name="Rounded Rectangle 9"/>
           <p:cNvSpPr/>
           <p:nvPr/>
         </p:nvSpPr>
@@ -9570,8 +8326,8 @@
         </p:nvSpPr>
         <p:spPr>
           <a:xfrm>
-            <a:off x="1054565" y="985640"/>
-            <a:ext cx="16178870" cy="1069521"/>
+            <a:off x="4422448" y="923093"/>
+            <a:ext cx="8840169" cy="1185092"/>
           </a:xfrm>
           <a:prstGeom prst="rect">
             <a:avLst/>
@@ -9585,7 +8341,7 @@
           <a:p>
             <a:pPr algn="ctr">
               <a:lnSpc>
-                <a:spcPts val="8250"/>
+                <a:spcPts val="9230"/>
               </a:lnSpc>
               <a:spcBef>
                 <a:spcPct val="0"/>
@@ -9601,28 +8357,133 @@
                 <a:cs typeface="Poppins Bold" panose="00000800000000000000"/>
                 <a:sym typeface="Poppins Bold" panose="00000800000000000000"/>
               </a:rPr>
-              <a:t>Methodology(Process / Workflow)</a:t>
-            </a:r>
-          </a:p>
-        </p:txBody>
-      </p:sp>
-      <p:sp>
-        <p:nvSpPr>
-          <p:cNvPr id="6" name="TextBox 6"/>
+              <a:t>Problem Statement </a:t>
+            </a:r>
+          </a:p>
+        </p:txBody>
+      </p:sp>
+      <p:sp>
+        <p:nvSpPr>
+          <p:cNvPr id="9" name="Oval 8"/>
+          <p:cNvSpPr/>
+          <p:nvPr/>
+        </p:nvSpPr>
+        <p:spPr>
+          <a:xfrm>
+            <a:off x="925233" y="4366971"/>
+            <a:ext cx="1524862" cy="1524862"/>
+          </a:xfrm>
+          <a:prstGeom prst="ellipse">
+            <a:avLst/>
+          </a:prstGeom>
+          <a:solidFill>
+            <a:srgbClr val="FCE7DC"/>
+          </a:solidFill>
+          <a:ln>
+            <a:noFill/>
+          </a:ln>
+          <a:effectLst/>
+        </p:spPr>
+        <p:style>
+          <a:lnRef idx="1">
+            <a:schemeClr val="accent1"/>
+          </a:lnRef>
+          <a:fillRef idx="3">
+            <a:schemeClr val="accent1"/>
+          </a:fillRef>
+          <a:effectRef idx="2">
+            <a:schemeClr val="accent1"/>
+          </a:effectRef>
+          <a:fontRef idx="minor">
+            <a:schemeClr val="lt1"/>
+          </a:fontRef>
+        </p:style>
+        <p:txBody>
+          <a:bodyPr rtlCol="0" anchor="ctr"/>
+          <a:lstStyle/>
+          <a:p>
+            <a:pPr algn="ctr"/>
+            <a:endParaRPr/>
+          </a:p>
+        </p:txBody>
+      </p:sp>
+      <p:sp>
+        <p:nvSpPr>
+          <p:cNvPr id="7" name="Freeform 7"/>
+          <p:cNvSpPr/>
+          <p:nvPr/>
+        </p:nvSpPr>
+        <p:spPr>
+          <a:xfrm>
+            <a:off x="734625" y="4263003"/>
+            <a:ext cx="1906078" cy="1732798"/>
+          </a:xfrm>
+          <a:custGeom>
+            <a:avLst/>
+            <a:gdLst/>
+            <a:ahLst/>
+            <a:cxnLst/>
+            <a:rect l="l" t="t" r="r" b="b"/>
+            <a:pathLst>
+              <a:path w="1906078" h="1732798">
+                <a:moveTo>
+                  <a:pt x="0" y="0"/>
+                </a:moveTo>
+                <a:lnTo>
+                  <a:pt x="1906078" y="0"/>
+                </a:lnTo>
+                <a:lnTo>
+                  <a:pt x="1906078" y="1732798"/>
+                </a:lnTo>
+                <a:lnTo>
+                  <a:pt x="0" y="1732798"/>
+                </a:lnTo>
+                <a:lnTo>
+                  <a:pt x="0" y="0"/>
+                </a:lnTo>
+                <a:close/>
+              </a:path>
+            </a:pathLst>
+          </a:custGeom>
+          <a:blipFill>
+            <a:blip>
+              <a:extLst>
+                <a:ext uri="{96DAC541-7B7A-43D3-8B79-37D633B846F1}">
+                  <asvg:svgBlip xmlns:asvg="http://schemas.microsoft.com/office/drawing/2016/SVG/main" r:embed="rId2"/>
+                </a:ext>
+              </a:extLst>
+            </a:blip>
+            <a:stretch>
+              <a:fillRect/>
+            </a:stretch>
+          </a:blipFill>
+        </p:spPr>
+        <p:txBody>
+          <a:bodyPr/>
+          <a:lstStyle/>
+          <a:p>
+            <a:endParaRPr lang="en-IN"/>
+          </a:p>
+        </p:txBody>
+      </p:sp>
+      <p:sp>
+        <p:nvSpPr>
+          <p:cNvPr id="8" name="TextBox 7"/>
           <p:cNvSpPr txBox="1"/>
           <p:nvPr/>
         </p:nvSpPr>
         <p:spPr>
           <a:xfrm>
-            <a:off x="2406709" y="3231254"/>
-            <a:ext cx="15200000" cy="3205621"/>
+            <a:off x="2860631" y="4131254"/>
+            <a:ext cx="15200000" cy="2200000"/>
           </a:xfrm>
           <a:prstGeom prst="rect">
             <a:avLst/>
           </a:prstGeom>
+          <a:noFill/>
         </p:spPr>
         <p:txBody>
-          <a:bodyPr wrap="square" lIns="0" tIns="0" rIns="0" bIns="0" rtlCol="0" anchor="t">
+          <a:bodyPr wrap="square">
             <a:spAutoFit/>
           </a:bodyPr>
           <a:lstStyle/>
@@ -9636,6 +8497,1595 @@
               </a:spcAft>
             </a:pPr>
             <a:r>
+              <a:rPr lang="en-US" sz="2600" b="1">
+                <a:solidFill>
+                  <a:srgbClr val="112D63"/>
+                </a:solidFill>
+                <a:latin typeface="Calibri" panose="020F0502020204030204"/>
+              </a:rPr>
+              <a:t>Why this project matters:</a:t>
+            </a:r>
+          </a:p>
+          <a:p>
+            <a:pPr algn="l">
+              <a:lnSpc>
+                <a:spcPts val="4235"/>
+              </a:lnSpc>
+              <a:spcAft>
+                <a:spcPts val="1000"/>
+              </a:spcAft>
+              <a:buNone/>
+            </a:pPr>
+            <a:r>
+              <a:rPr sz="2500" b="0" i="0">
+                <a:solidFill>
+                  <a:srgbClr val="3F3F3F"/>
+                </a:solidFill>
+                <a:latin typeface="Calibri" panose="020F0502020204030204"/>
+              </a:rPr>
+              <a:t>Rising global temperatures are reshaping weather, sea levels and ecosystems, but the scale of this change is hard to grasp from raw numbers alone.</a:t>
+            </a:r>
+          </a:p>
+          <a:p>
+            <a:pPr algn="l">
+              <a:lnSpc>
+                <a:spcPts val="4235"/>
+              </a:lnSpc>
+              <a:spcAft>
+                <a:spcPts val="1000"/>
+              </a:spcAft>
+              <a:buNone/>
+            </a:pPr>
+            <a:endParaRPr sz="2500" b="0" i="0">
+              <a:solidFill>
+                <a:srgbClr val="3F3F3F"/>
+              </a:solidFill>
+              <a:latin typeface="Calibri" panose="020F0502020204030204"/>
+            </a:endParaRPr>
+          </a:p>
+          <a:p>
+            <a:pPr algn="l">
+              <a:lnSpc>
+                <a:spcPts val="4235"/>
+              </a:lnSpc>
+              <a:spcAft>
+                <a:spcPts val="1000"/>
+              </a:spcAft>
+              <a:buNone/>
+            </a:pPr>
+            <a:r>
+              <a:rPr sz="2500" b="0" i="0">
+                <a:solidFill>
+                  <a:srgbClr val="3F3F3F"/>
+                </a:solidFill>
+                <a:latin typeface="Calibri" panose="020F0502020204030204"/>
+              </a:rPr>
+              <a:t>This project uses 124 years of country-level climate data (1900-2023) to show, in a clear visual way, how much the planet has actually warmed and where that warming is happening fastest.</a:t>
+            </a:r>
+          </a:p>
+        </p:txBody>
+      </p:sp>
+      <p:sp>
+        <p:nvSpPr>
+          <p:cNvPr id="11" name="Rounded Rectangle 10"/>
+          <p:cNvSpPr/>
+          <p:nvPr/>
+        </p:nvSpPr>
+        <p:spPr>
+          <a:xfrm>
+            <a:off x="2860631" y="8000000"/>
+            <a:ext cx="4333333" cy="1300000"/>
+          </a:xfrm>
+          <a:prstGeom prst="roundRect">
+            <a:avLst>
+              <a:gd name="adj" fmla="val 8000"/>
+            </a:avLst>
+          </a:prstGeom>
+          <a:solidFill>
+            <a:srgbClr val="F4F8FD"/>
+          </a:solidFill>
+          <a:ln w="12700">
+            <a:solidFill>
+              <a:srgbClr val="E1E8F2"/>
+            </a:solidFill>
+          </a:ln>
+          <a:effectLst/>
+        </p:spPr>
+        <p:style>
+          <a:lnRef idx="1">
+            <a:schemeClr val="accent1"/>
+          </a:lnRef>
+          <a:fillRef idx="3">
+            <a:schemeClr val="accent1"/>
+          </a:fillRef>
+          <a:effectRef idx="2">
+            <a:schemeClr val="accent1"/>
+          </a:effectRef>
+          <a:fontRef idx="minor">
+            <a:schemeClr val="lt1"/>
+          </a:fontRef>
+        </p:style>
+        <p:txBody>
+          <a:bodyPr wrap="square" lIns="60000" tIns="120000" rIns="60000" rtlCol="0" anchor="ctr"/>
+          <a:lstStyle/>
+          <a:p>
+            <a:pPr algn="ctr"/>
+            <a:r>
+              <a:rPr sz="3000" b="1">
+                <a:solidFill>
+                  <a:srgbClr val="112D63"/>
+                </a:solidFill>
+                <a:latin typeface="Calibri" panose="020F0502020204030204"/>
+              </a:rPr>
+              <a:t>1900–2023</a:t>
+            </a:r>
+          </a:p>
+          <a:p>
+            <a:pPr algn="ctr"/>
+            <a:r>
+              <a:rPr sz="1400" b="0">
+                <a:solidFill>
+                  <a:srgbClr val="5A6472"/>
+                </a:solidFill>
+                <a:latin typeface="Calibri" panose="020F0502020204030204"/>
+              </a:rPr>
+              <a:t>Years of climate data</a:t>
+            </a:r>
+          </a:p>
+        </p:txBody>
+      </p:sp>
+      <p:sp>
+        <p:nvSpPr>
+          <p:cNvPr id="12" name="Rounded Rectangle 11"/>
+          <p:cNvSpPr/>
+          <p:nvPr/>
+        </p:nvSpPr>
+        <p:spPr>
+          <a:xfrm>
+            <a:off x="7443964" y="8000000"/>
+            <a:ext cx="4333333" cy="1300000"/>
+          </a:xfrm>
+          <a:prstGeom prst="roundRect">
+            <a:avLst>
+              <a:gd name="adj" fmla="val 8000"/>
+            </a:avLst>
+          </a:prstGeom>
+          <a:solidFill>
+            <a:srgbClr val="F4F8FD"/>
+          </a:solidFill>
+          <a:ln w="12700">
+            <a:solidFill>
+              <a:srgbClr val="E1E8F2"/>
+            </a:solidFill>
+          </a:ln>
+          <a:effectLst/>
+        </p:spPr>
+        <p:style>
+          <a:lnRef idx="1">
+            <a:schemeClr val="accent1"/>
+          </a:lnRef>
+          <a:fillRef idx="3">
+            <a:schemeClr val="accent1"/>
+          </a:fillRef>
+          <a:effectRef idx="2">
+            <a:schemeClr val="accent1"/>
+          </a:effectRef>
+          <a:fontRef idx="minor">
+            <a:schemeClr val="lt1"/>
+          </a:fontRef>
+        </p:style>
+        <p:txBody>
+          <a:bodyPr wrap="square" lIns="60000" tIns="120000" rIns="60000" rtlCol="0" anchor="ctr"/>
+          <a:lstStyle/>
+          <a:p>
+            <a:pPr algn="ctr"/>
+            <a:r>
+              <a:rPr sz="3000" b="1">
+                <a:solidFill>
+                  <a:srgbClr val="112D63"/>
+                </a:solidFill>
+                <a:latin typeface="Calibri" panose="020F0502020204030204"/>
+              </a:rPr>
+              <a:t>195</a:t>
+            </a:r>
+          </a:p>
+          <a:p>
+            <a:pPr algn="ctr"/>
+            <a:r>
+              <a:rPr sz="1400" b="0">
+                <a:solidFill>
+                  <a:srgbClr val="5A6472"/>
+                </a:solidFill>
+                <a:latin typeface="Calibri" panose="020F0502020204030204"/>
+              </a:rPr>
+              <a:t>Countries covered</a:t>
+            </a:r>
+          </a:p>
+        </p:txBody>
+      </p:sp>
+      <p:sp>
+        <p:nvSpPr>
+          <p:cNvPr id="13" name="Rounded Rectangle 12"/>
+          <p:cNvSpPr/>
+          <p:nvPr/>
+        </p:nvSpPr>
+        <p:spPr>
+          <a:xfrm>
+            <a:off x="12027297" y="8000000"/>
+            <a:ext cx="4333333" cy="1300000"/>
+          </a:xfrm>
+          <a:prstGeom prst="roundRect">
+            <a:avLst>
+              <a:gd name="adj" fmla="val 8000"/>
+            </a:avLst>
+          </a:prstGeom>
+          <a:solidFill>
+            <a:srgbClr val="F4F8FD"/>
+          </a:solidFill>
+          <a:ln w="12700">
+            <a:solidFill>
+              <a:srgbClr val="E1E8F2"/>
+            </a:solidFill>
+          </a:ln>
+          <a:effectLst/>
+        </p:spPr>
+        <p:style>
+          <a:lnRef idx="1">
+            <a:schemeClr val="accent1"/>
+          </a:lnRef>
+          <a:fillRef idx="3">
+            <a:schemeClr val="accent1"/>
+          </a:fillRef>
+          <a:effectRef idx="2">
+            <a:schemeClr val="accent1"/>
+          </a:effectRef>
+          <a:fontRef idx="minor">
+            <a:schemeClr val="lt1"/>
+          </a:fontRef>
+        </p:style>
+        <p:txBody>
+          <a:bodyPr wrap="square" lIns="60000" tIns="120000" rIns="60000" rtlCol="0" anchor="ctr"/>
+          <a:lstStyle/>
+          <a:p>
+            <a:pPr algn="ctr"/>
+            <a:r>
+              <a:rPr sz="3000" b="1">
+                <a:solidFill>
+                  <a:srgbClr val="112D63"/>
+                </a:solidFill>
+                <a:latin typeface="Calibri" panose="020F0502020204030204"/>
+              </a:rPr>
+              <a:t>100,000</a:t>
+            </a:r>
+          </a:p>
+          <a:p>
+            <a:pPr algn="ctr"/>
+            <a:r>
+              <a:rPr sz="1400" b="0">
+                <a:solidFill>
+                  <a:srgbClr val="5A6472"/>
+                </a:solidFill>
+                <a:latin typeface="Calibri" panose="020F0502020204030204"/>
+              </a:rPr>
+              <a:t>Records analyzed</a:t>
+            </a:r>
+          </a:p>
+        </p:txBody>
+      </p:sp>
+    </p:spTree>
+  </p:cSld>
+  <p:clrMapOvr>
+    <a:masterClrMapping/>
+  </p:clrMapOvr>
+</p:sld>
+</file>
+
+<file path=ppt/slides/slide3.xml><?xml version="1.0" encoding="utf-8"?>
+<p:sld xmlns:a="http://schemas.openxmlformats.org/drawingml/2006/main" xmlns:r="http://schemas.openxmlformats.org/officeDocument/2006/relationships" xmlns:p="http://schemas.openxmlformats.org/presentationml/2006/main">
+  <p:cSld>
+    <p:bg>
+      <p:bgPr>
+        <a:solidFill>
+          <a:srgbClr val="F5FFFF"/>
+        </a:solidFill>
+        <a:effectLst/>
+      </p:bgPr>
+    </p:bg>
+    <p:spTree>
+      <p:nvGrpSpPr>
+        <p:cNvPr id="1" name=""/>
+        <p:cNvGrpSpPr/>
+        <p:nvPr/>
+      </p:nvGrpSpPr>
+      <p:grpSpPr>
+        <a:xfrm>
+          <a:off x="0" y="0"/>
+          <a:ext cx="0" cy="0"/>
+          <a:chOff x="0" y="0"/>
+          <a:chExt cx="0" cy="0"/>
+        </a:xfrm>
+      </p:grpSpPr>
+      <p:grpSp>
+        <p:nvGrpSpPr>
+          <p:cNvPr id="2" name="Group 2"/>
+          <p:cNvGrpSpPr/>
+          <p:nvPr/>
+        </p:nvGrpSpPr>
+        <p:grpSpPr>
+          <a:xfrm>
+            <a:off x="0" y="576841"/>
+            <a:ext cx="18288000" cy="2058570"/>
+            <a:chOff x="0" y="0"/>
+            <a:chExt cx="3738189" cy="420785"/>
+          </a:xfrm>
+        </p:grpSpPr>
+        <p:sp>
+          <p:nvSpPr>
+            <p:cNvPr id="3" name="Freeform 3"/>
+            <p:cNvSpPr/>
+            <p:nvPr/>
+          </p:nvSpPr>
+          <p:spPr>
+            <a:xfrm>
+              <a:off x="0" y="0"/>
+              <a:ext cx="3738189" cy="420785"/>
+            </a:xfrm>
+            <a:custGeom>
+              <a:avLst/>
+              <a:gdLst/>
+              <a:ahLst/>
+              <a:cxnLst/>
+              <a:rect l="l" t="t" r="r" b="b"/>
+              <a:pathLst>
+                <a:path w="3738189" h="420785">
+                  <a:moveTo>
+                    <a:pt x="3534989" y="0"/>
+                  </a:moveTo>
+                  <a:lnTo>
+                    <a:pt x="0" y="0"/>
+                  </a:lnTo>
+                  <a:lnTo>
+                    <a:pt x="0" y="420785"/>
+                  </a:lnTo>
+                  <a:lnTo>
+                    <a:pt x="3534989" y="420785"/>
+                  </a:lnTo>
+                  <a:lnTo>
+                    <a:pt x="3738189" y="210393"/>
+                  </a:lnTo>
+                  <a:lnTo>
+                    <a:pt x="3534989" y="0"/>
+                  </a:lnTo>
+                  <a:close/>
+                </a:path>
+              </a:pathLst>
+            </a:custGeom>
+            <a:solidFill>
+              <a:srgbClr val="112D63"/>
+            </a:solidFill>
+            <a:ln w="19050" cap="sq">
+              <a:solidFill>
+                <a:srgbClr val="112D63"/>
+              </a:solidFill>
+              <a:prstDash val="solid"/>
+              <a:miter/>
+            </a:ln>
+          </p:spPr>
+          <p:txBody>
+            <a:bodyPr/>
+            <a:lstStyle/>
+            <a:p>
+              <a:endParaRPr lang="en-IN"/>
+            </a:p>
+          </p:txBody>
+        </p:sp>
+        <p:sp>
+          <p:nvSpPr>
+            <p:cNvPr id="4" name="TextBox 4"/>
+            <p:cNvSpPr txBox="1"/>
+            <p:nvPr/>
+          </p:nvSpPr>
+          <p:spPr>
+            <a:xfrm>
+              <a:off x="0" y="-66675"/>
+              <a:ext cx="3623889" cy="487460"/>
+            </a:xfrm>
+            <a:prstGeom prst="rect">
+              <a:avLst/>
+            </a:prstGeom>
+          </p:spPr>
+          <p:txBody>
+            <a:bodyPr lIns="50800" tIns="50800" rIns="50800" bIns="50800" rtlCol="0" anchor="ctr"/>
+            <a:lstStyle/>
+            <a:p>
+              <a:pPr algn="ctr">
+                <a:lnSpc>
+                  <a:spcPts val="2800"/>
+                </a:lnSpc>
+              </a:pPr>
+              <a:endParaRPr/>
+            </a:p>
+          </p:txBody>
+        </p:sp>
+      </p:grpSp>
+      <p:sp>
+        <p:nvSpPr>
+          <p:cNvPr id="9" name="Rounded Rectangle 8"/>
+          <p:cNvSpPr/>
+          <p:nvPr/>
+        </p:nvSpPr>
+        <p:spPr>
+          <a:xfrm>
+            <a:off x="150000" y="2750000"/>
+            <a:ext cx="17988000" cy="6950000"/>
+          </a:xfrm>
+          <a:prstGeom prst="roundRect">
+            <a:avLst>
+              <a:gd name="adj" fmla="val 3500"/>
+            </a:avLst>
+          </a:prstGeom>
+          <a:solidFill>
+            <a:srgbClr val="FBFDFF"/>
+          </a:solidFill>
+          <a:ln w="12700">
+            <a:solidFill>
+              <a:srgbClr val="E1E8F2"/>
+            </a:solidFill>
+          </a:ln>
+          <a:effectLst/>
+        </p:spPr>
+        <p:style>
+          <a:lnRef idx="1">
+            <a:schemeClr val="accent1"/>
+          </a:lnRef>
+          <a:fillRef idx="3">
+            <a:schemeClr val="accent1"/>
+          </a:fillRef>
+          <a:effectRef idx="2">
+            <a:schemeClr val="accent1"/>
+          </a:effectRef>
+          <a:fontRef idx="minor">
+            <a:schemeClr val="lt1"/>
+          </a:fontRef>
+        </p:style>
+        <p:txBody>
+          <a:bodyPr rtlCol="0" anchor="ctr"/>
+          <a:lstStyle/>
+          <a:p>
+            <a:pPr algn="ctr"/>
+            <a:endParaRPr/>
+          </a:p>
+        </p:txBody>
+      </p:sp>
+      <p:sp>
+        <p:nvSpPr>
+          <p:cNvPr id="5" name="TextBox 5"/>
+          <p:cNvSpPr txBox="1"/>
+          <p:nvPr/>
+        </p:nvSpPr>
+        <p:spPr>
+          <a:xfrm>
+            <a:off x="4422448" y="923093"/>
+            <a:ext cx="8840169" cy="1185092"/>
+          </a:xfrm>
+          <a:prstGeom prst="rect">
+            <a:avLst/>
+          </a:prstGeom>
+        </p:spPr>
+        <p:txBody>
+          <a:bodyPr lIns="0" tIns="0" rIns="0" bIns="0" rtlCol="0" anchor="t">
+            <a:spAutoFit/>
+          </a:bodyPr>
+          <a:lstStyle/>
+          <a:p>
+            <a:pPr algn="ctr">
+              <a:lnSpc>
+                <a:spcPts val="9230"/>
+              </a:lnSpc>
+              <a:spcBef>
+                <a:spcPct val="0"/>
+              </a:spcBef>
+            </a:pPr>
+            <a:r>
+              <a:rPr lang="en-US" sz="4000" b="1">
+                <a:solidFill>
+                  <a:srgbClr val="FFFFFF"/>
+                </a:solidFill>
+                <a:latin typeface="Poppins Bold" panose="00000800000000000000"/>
+                <a:ea typeface="Poppins Bold" panose="00000800000000000000"/>
+                <a:cs typeface="Poppins Bold" panose="00000800000000000000"/>
+                <a:sym typeface="Poppins Bold" panose="00000800000000000000"/>
+              </a:rPr>
+              <a:t>Project Objectives</a:t>
+            </a:r>
+          </a:p>
+        </p:txBody>
+      </p:sp>
+      <p:sp>
+        <p:nvSpPr>
+          <p:cNvPr id="6" name="TextBox 6"/>
+          <p:cNvSpPr txBox="1"/>
+          <p:nvPr/>
+        </p:nvSpPr>
+        <p:spPr>
+          <a:xfrm>
+            <a:off x="2860631" y="4607276"/>
+            <a:ext cx="15400000" cy="505523"/>
+          </a:xfrm>
+          <a:prstGeom prst="rect">
+            <a:avLst/>
+          </a:prstGeom>
+        </p:spPr>
+        <p:txBody>
+          <a:bodyPr wrap="square" lIns="0" tIns="0" rIns="0" bIns="0" rtlCol="0" anchor="t">
+            <a:spAutoFit/>
+          </a:bodyPr>
+          <a:lstStyle/>
+          <a:p>
+            <a:pPr marL="652780" lvl="1" indent="-326390" algn="l">
+              <a:lnSpc>
+                <a:spcPts val="4235"/>
+              </a:lnSpc>
+              <a:spcBef>
+                <a:spcPct val="0"/>
+              </a:spcBef>
+              <a:spcAft>
+                <a:spcPts val="1000"/>
+              </a:spcAft>
+              <a:buClr>
+                <a:srgbClr val="E8622C"/>
+              </a:buClr>
+              <a:buFont typeface="Arial" panose="020B0604020202020204"/>
+              <a:buChar char="•"/>
+            </a:pPr>
+            <a:r>
+              <a:rPr lang="en-US" sz="2500" b="0" i="0" dirty="0">
+                <a:solidFill>
+                  <a:srgbClr val="3F3F3F"/>
+                </a:solidFill>
+                <a:latin typeface="Calibri" panose="020F0502020204030204"/>
+                <a:ea typeface="Calibri" panose="020F0502020204030204"/>
+                <a:cs typeface="Calibri" panose="020F0502020204030204"/>
+              </a:rPr>
+              <a:t>We explore historical temperature anomaly data from 1900 to 2023 across 195 countries.</a:t>
+            </a:r>
+            <a:endParaRPr lang="en-US" sz="3000" dirty="0">
+              <a:solidFill>
+                <a:srgbClr val="545454"/>
+              </a:solidFill>
+              <a:ea typeface="Calibri" panose="020F0502020204030204"/>
+              <a:cs typeface="Calibri" panose="020F0502020204030204"/>
+            </a:endParaRPr>
+          </a:p>
+          <a:p>
+            <a:pPr marL="652780" lvl="1" indent="-326390" algn="l">
+              <a:lnSpc>
+                <a:spcPts val="4235"/>
+              </a:lnSpc>
+              <a:spcBef>
+                <a:spcPct val="0"/>
+              </a:spcBef>
+              <a:spcAft>
+                <a:spcPts val="1000"/>
+              </a:spcAft>
+              <a:buClr>
+                <a:srgbClr val="E8622C"/>
+              </a:buClr>
+              <a:buFont typeface="Arial" panose="020B0604020202020204"/>
+              <a:buChar char="•"/>
+            </a:pPr>
+            <a:r>
+              <a:rPr lang="en-US" sz="2500" b="0" i="0" dirty="0">
+                <a:solidFill>
+                  <a:srgbClr val="3F3F3F"/>
+                </a:solidFill>
+                <a:latin typeface="Calibri" panose="020F0502020204030204"/>
+                <a:ea typeface="Calibri" panose="020F0502020204030204"/>
+                <a:cs typeface="Calibri" panose="020F0502020204030204"/>
+              </a:rPr>
+              <a:t>We identify long-term warming trends and patterns across different regions and decades.</a:t>
+            </a:r>
+            <a:endParaRPr lang="en-US" sz="3000" dirty="0">
+              <a:solidFill>
+                <a:srgbClr val="545454"/>
+              </a:solidFill>
+              <a:ea typeface="Calibri" panose="020F0502020204030204"/>
+              <a:cs typeface="Calibri" panose="020F0502020204030204"/>
+            </a:endParaRPr>
+          </a:p>
+          <a:p>
+            <a:pPr marL="652780" lvl="1" indent="-326390" algn="l">
+              <a:lnSpc>
+                <a:spcPts val="4235"/>
+              </a:lnSpc>
+              <a:spcBef>
+                <a:spcPct val="0"/>
+              </a:spcBef>
+              <a:spcAft>
+                <a:spcPts val="1000"/>
+              </a:spcAft>
+              <a:buClr>
+                <a:srgbClr val="E8622C"/>
+              </a:buClr>
+              <a:buFont typeface="Arial" panose="020B0604020202020204"/>
+              <a:buChar char="•"/>
+            </a:pPr>
+            <a:r>
+              <a:rPr lang="en-US" sz="2500" b="0" i="0" dirty="0">
+                <a:solidFill>
+                  <a:srgbClr val="3F3F3F"/>
+                </a:solidFill>
+                <a:latin typeface="Calibri" panose="020F0502020204030204"/>
+                <a:ea typeface="Calibri" panose="020F0502020204030204"/>
+                <a:cs typeface="Calibri" panose="020F0502020204030204"/>
+              </a:rPr>
+              <a:t>We clean the dataset thoroughly, handling missing values and outliers so the analysis stays reliable.</a:t>
+            </a:r>
+            <a:endParaRPr lang="en-US" sz="3000" dirty="0">
+              <a:solidFill>
+                <a:srgbClr val="545454"/>
+              </a:solidFill>
+              <a:ea typeface="Calibri" panose="020F0502020204030204"/>
+              <a:cs typeface="Calibri" panose="020F0502020204030204"/>
+            </a:endParaRPr>
+          </a:p>
+          <a:p>
+            <a:pPr marL="652780" lvl="1" indent="-326390" algn="l">
+              <a:lnSpc>
+                <a:spcPts val="4235"/>
+              </a:lnSpc>
+              <a:spcBef>
+                <a:spcPct val="0"/>
+              </a:spcBef>
+              <a:spcAft>
+                <a:spcPts val="1000"/>
+              </a:spcAft>
+              <a:buClr>
+                <a:srgbClr val="E8622C"/>
+              </a:buClr>
+              <a:buFont typeface="Arial" panose="020B0604020202020204"/>
+              <a:buChar char="•"/>
+            </a:pPr>
+            <a:r>
+              <a:rPr lang="en-US" sz="2500" b="0" i="0" dirty="0">
+                <a:solidFill>
+                  <a:srgbClr val="3F3F3F"/>
+                </a:solidFill>
+                <a:latin typeface="Calibri" panose="020F0502020204030204"/>
+                <a:ea typeface="Calibri" panose="020F0502020204030204"/>
+                <a:cs typeface="Calibri" panose="020F0502020204030204"/>
+              </a:rPr>
+              <a:t>We aim to build a clear, animated "warming stripes" visualization that communicates climate change simply.</a:t>
+            </a:r>
+            <a:endParaRPr lang="en-US" sz="3000" dirty="0">
+              <a:solidFill>
+                <a:srgbClr val="545454"/>
+              </a:solidFill>
+              <a:ea typeface="Calibri" panose="020F0502020204030204"/>
+              <a:cs typeface="Calibri" panose="020F0502020204030204"/>
+            </a:endParaRPr>
+          </a:p>
+          <a:p>
+            <a:pPr marL="652780" lvl="1" indent="-326390" algn="l">
+              <a:lnSpc>
+                <a:spcPts val="4235"/>
+              </a:lnSpc>
+              <a:spcBef>
+                <a:spcPct val="0"/>
+              </a:spcBef>
+              <a:spcAft>
+                <a:spcPts val="1000"/>
+              </a:spcAft>
+              <a:buClr>
+                <a:srgbClr val="E8622C"/>
+              </a:buClr>
+              <a:buFont typeface="Arial" panose="020B0604020202020204"/>
+              <a:buChar char="•"/>
+            </a:pPr>
+            <a:r>
+              <a:rPr sz="2500" b="0" i="0">
+                <a:solidFill>
+                  <a:srgbClr val="3F3F3F"/>
+                </a:solidFill>
+                <a:latin typeface="Calibri" panose="020F0502020204030204"/>
+              </a:rPr>
+              <a:t>We document our process clearly each week so our GitHub repo tells the full story of the project.</a:t>
+            </a:r>
+            <a:endParaRPr lang="en-US" sz="3000" dirty="0">
+              <a:solidFill>
+                <a:srgbClr val="545454"/>
+              </a:solidFill>
+              <a:ea typeface="Calibri" panose="020F0502020204030204"/>
+              <a:cs typeface="Calibri" panose="020F0502020204030204"/>
+            </a:endParaRPr>
+          </a:p>
+        </p:txBody>
+      </p:sp>
+      <p:sp>
+        <p:nvSpPr>
+          <p:cNvPr id="8" name="Oval 7"/>
+          <p:cNvSpPr/>
+          <p:nvPr/>
+        </p:nvSpPr>
+        <p:spPr>
+          <a:xfrm>
+            <a:off x="901573" y="4198124"/>
+            <a:ext cx="1462556" cy="1462556"/>
+          </a:xfrm>
+          <a:prstGeom prst="ellipse">
+            <a:avLst/>
+          </a:prstGeom>
+          <a:solidFill>
+            <a:srgbClr val="FCE7DC"/>
+          </a:solidFill>
+          <a:ln>
+            <a:noFill/>
+          </a:ln>
+          <a:effectLst/>
+        </p:spPr>
+        <p:style>
+          <a:lnRef idx="1">
+            <a:schemeClr val="accent1"/>
+          </a:lnRef>
+          <a:fillRef idx="3">
+            <a:schemeClr val="accent1"/>
+          </a:fillRef>
+          <a:effectRef idx="2">
+            <a:schemeClr val="accent1"/>
+          </a:effectRef>
+          <a:fontRef idx="minor">
+            <a:schemeClr val="lt1"/>
+          </a:fontRef>
+        </p:style>
+        <p:txBody>
+          <a:bodyPr rtlCol="0" anchor="ctr"/>
+          <a:lstStyle/>
+          <a:p>
+            <a:pPr algn="ctr"/>
+            <a:endParaRPr/>
+          </a:p>
+        </p:txBody>
+      </p:sp>
+      <p:sp>
+        <p:nvSpPr>
+          <p:cNvPr id="7" name="Freeform 7"/>
+          <p:cNvSpPr/>
+          <p:nvPr/>
+        </p:nvSpPr>
+        <p:spPr>
+          <a:xfrm>
+            <a:off x="718753" y="4015304"/>
+            <a:ext cx="1828196" cy="1828196"/>
+          </a:xfrm>
+          <a:custGeom>
+            <a:avLst/>
+            <a:gdLst/>
+            <a:ahLst/>
+            <a:cxnLst/>
+            <a:rect l="l" t="t" r="r" b="b"/>
+            <a:pathLst>
+              <a:path w="1828196" h="1828196">
+                <a:moveTo>
+                  <a:pt x="0" y="0"/>
+                </a:moveTo>
+                <a:lnTo>
+                  <a:pt x="1828196" y="0"/>
+                </a:lnTo>
+                <a:lnTo>
+                  <a:pt x="1828196" y="1828196"/>
+                </a:lnTo>
+                <a:lnTo>
+                  <a:pt x="0" y="1828196"/>
+                </a:lnTo>
+                <a:lnTo>
+                  <a:pt x="0" y="0"/>
+                </a:lnTo>
+                <a:close/>
+              </a:path>
+            </a:pathLst>
+          </a:custGeom>
+          <a:blipFill>
+            <a:blip>
+              <a:extLst>
+                <a:ext uri="{96DAC541-7B7A-43D3-8B79-37D633B846F1}">
+                  <asvg:svgBlip xmlns:asvg="http://schemas.microsoft.com/office/drawing/2016/SVG/main" r:embed="rId2"/>
+                </a:ext>
+              </a:extLst>
+            </a:blip>
+            <a:stretch>
+              <a:fillRect/>
+            </a:stretch>
+          </a:blipFill>
+        </p:spPr>
+        <p:txBody>
+          <a:bodyPr/>
+          <a:lstStyle/>
+          <a:p>
+            <a:endParaRPr lang="en-IN"/>
+          </a:p>
+        </p:txBody>
+      </p:sp>
+    </p:spTree>
+  </p:cSld>
+  <p:clrMapOvr>
+    <a:masterClrMapping/>
+  </p:clrMapOvr>
+</p:sld>
+</file>
+
+<file path=ppt/slides/slide4.xml><?xml version="1.0" encoding="utf-8"?>
+<p:sld xmlns:a="http://schemas.openxmlformats.org/drawingml/2006/main" xmlns:r="http://schemas.openxmlformats.org/officeDocument/2006/relationships" xmlns:p="http://schemas.openxmlformats.org/presentationml/2006/main">
+  <p:cSld>
+    <p:bg>
+      <p:bgPr>
+        <a:solidFill>
+          <a:srgbClr val="F5FFFF"/>
+        </a:solidFill>
+        <a:effectLst/>
+      </p:bgPr>
+    </p:bg>
+    <p:spTree>
+      <p:nvGrpSpPr>
+        <p:cNvPr id="1" name=""/>
+        <p:cNvGrpSpPr/>
+        <p:nvPr/>
+      </p:nvGrpSpPr>
+      <p:grpSpPr>
+        <a:xfrm>
+          <a:off x="0" y="0"/>
+          <a:ext cx="0" cy="0"/>
+          <a:chOff x="0" y="0"/>
+          <a:chExt cx="0" cy="0"/>
+        </a:xfrm>
+      </p:grpSpPr>
+      <p:grpSp>
+        <p:nvGrpSpPr>
+          <p:cNvPr id="2" name="Group 2"/>
+          <p:cNvGrpSpPr/>
+          <p:nvPr/>
+        </p:nvGrpSpPr>
+        <p:grpSpPr>
+          <a:xfrm>
+            <a:off x="0" y="576841"/>
+            <a:ext cx="18288000" cy="2058570"/>
+            <a:chOff x="0" y="0"/>
+            <a:chExt cx="3738189" cy="420785"/>
+          </a:xfrm>
+        </p:grpSpPr>
+        <p:sp>
+          <p:nvSpPr>
+            <p:cNvPr id="3" name="Freeform 3"/>
+            <p:cNvSpPr/>
+            <p:nvPr/>
+          </p:nvSpPr>
+          <p:spPr>
+            <a:xfrm>
+              <a:off x="0" y="0"/>
+              <a:ext cx="3738189" cy="420785"/>
+            </a:xfrm>
+            <a:custGeom>
+              <a:avLst/>
+              <a:gdLst/>
+              <a:ahLst/>
+              <a:cxnLst/>
+              <a:rect l="l" t="t" r="r" b="b"/>
+              <a:pathLst>
+                <a:path w="3738189" h="420785">
+                  <a:moveTo>
+                    <a:pt x="3534989" y="0"/>
+                  </a:moveTo>
+                  <a:lnTo>
+                    <a:pt x="0" y="0"/>
+                  </a:lnTo>
+                  <a:lnTo>
+                    <a:pt x="0" y="420785"/>
+                  </a:lnTo>
+                  <a:lnTo>
+                    <a:pt x="3534989" y="420785"/>
+                  </a:lnTo>
+                  <a:lnTo>
+                    <a:pt x="3738189" y="210393"/>
+                  </a:lnTo>
+                  <a:lnTo>
+                    <a:pt x="3534989" y="0"/>
+                  </a:lnTo>
+                  <a:close/>
+                </a:path>
+              </a:pathLst>
+            </a:custGeom>
+            <a:solidFill>
+              <a:srgbClr val="112D63"/>
+            </a:solidFill>
+            <a:ln w="19050" cap="sq">
+              <a:solidFill>
+                <a:srgbClr val="112D63"/>
+              </a:solidFill>
+              <a:prstDash val="solid"/>
+              <a:miter/>
+            </a:ln>
+          </p:spPr>
+          <p:txBody>
+            <a:bodyPr/>
+            <a:lstStyle/>
+            <a:p>
+              <a:endParaRPr lang="en-IN"/>
+            </a:p>
+          </p:txBody>
+        </p:sp>
+        <p:sp>
+          <p:nvSpPr>
+            <p:cNvPr id="4" name="TextBox 4"/>
+            <p:cNvSpPr txBox="1"/>
+            <p:nvPr/>
+          </p:nvSpPr>
+          <p:spPr>
+            <a:xfrm>
+              <a:off x="0" y="-66675"/>
+              <a:ext cx="3623889" cy="487460"/>
+            </a:xfrm>
+            <a:prstGeom prst="rect">
+              <a:avLst/>
+            </a:prstGeom>
+          </p:spPr>
+          <p:txBody>
+            <a:bodyPr lIns="50800" tIns="50800" rIns="50800" bIns="50800" rtlCol="0" anchor="ctr"/>
+            <a:lstStyle/>
+            <a:p>
+              <a:pPr algn="ctr">
+                <a:lnSpc>
+                  <a:spcPts val="2800"/>
+                </a:lnSpc>
+              </a:pPr>
+              <a:endParaRPr/>
+            </a:p>
+          </p:txBody>
+        </p:sp>
+      </p:grpSp>
+      <p:sp>
+        <p:nvSpPr>
+          <p:cNvPr id="7" name="Rounded Rectangle 6"/>
+          <p:cNvSpPr/>
+          <p:nvPr/>
+        </p:nvSpPr>
+        <p:spPr>
+          <a:xfrm>
+            <a:off x="150000" y="2750000"/>
+            <a:ext cx="17988000" cy="6950000"/>
+          </a:xfrm>
+          <a:prstGeom prst="roundRect">
+            <a:avLst>
+              <a:gd name="adj" fmla="val 3500"/>
+            </a:avLst>
+          </a:prstGeom>
+          <a:solidFill>
+            <a:srgbClr val="FBFDFF"/>
+          </a:solidFill>
+          <a:ln w="12700">
+            <a:solidFill>
+              <a:srgbClr val="E1E8F2"/>
+            </a:solidFill>
+          </a:ln>
+          <a:effectLst/>
+        </p:spPr>
+        <p:style>
+          <a:lnRef idx="1">
+            <a:schemeClr val="accent1"/>
+          </a:lnRef>
+          <a:fillRef idx="3">
+            <a:schemeClr val="accent1"/>
+          </a:fillRef>
+          <a:effectRef idx="2">
+            <a:schemeClr val="accent1"/>
+          </a:effectRef>
+          <a:fontRef idx="minor">
+            <a:schemeClr val="lt1"/>
+          </a:fontRef>
+        </p:style>
+        <p:txBody>
+          <a:bodyPr rtlCol="0" anchor="ctr"/>
+          <a:lstStyle/>
+          <a:p>
+            <a:pPr algn="ctr"/>
+            <a:endParaRPr/>
+          </a:p>
+        </p:txBody>
+      </p:sp>
+      <p:sp>
+        <p:nvSpPr>
+          <p:cNvPr id="5" name="TextBox 5"/>
+          <p:cNvSpPr txBox="1"/>
+          <p:nvPr/>
+        </p:nvSpPr>
+        <p:spPr>
+          <a:xfrm>
+            <a:off x="4422448" y="923093"/>
+            <a:ext cx="8840169" cy="1185092"/>
+          </a:xfrm>
+          <a:prstGeom prst="rect">
+            <a:avLst/>
+          </a:prstGeom>
+        </p:spPr>
+        <p:txBody>
+          <a:bodyPr lIns="0" tIns="0" rIns="0" bIns="0" rtlCol="0" anchor="t">
+            <a:spAutoFit/>
+          </a:bodyPr>
+          <a:lstStyle/>
+          <a:p>
+            <a:pPr algn="ctr">
+              <a:lnSpc>
+                <a:spcPts val="9230"/>
+              </a:lnSpc>
+              <a:spcBef>
+                <a:spcPct val="0"/>
+              </a:spcBef>
+            </a:pPr>
+            <a:r>
+              <a:rPr lang="en-US" sz="4000" b="1">
+                <a:solidFill>
+                  <a:srgbClr val="FFFFFF"/>
+                </a:solidFill>
+                <a:latin typeface="Poppins Bold" panose="00000800000000000000"/>
+                <a:ea typeface="Poppins Bold" panose="00000800000000000000"/>
+                <a:cs typeface="Poppins Bold" panose="00000800000000000000"/>
+                <a:sym typeface="Poppins Bold" panose="00000800000000000000"/>
+              </a:rPr>
+              <a:t>Scope of the Project</a:t>
+            </a:r>
+          </a:p>
+        </p:txBody>
+      </p:sp>
+      <p:sp>
+        <p:nvSpPr>
+          <p:cNvPr id="6" name="TextBox 5"/>
+          <p:cNvSpPr txBox="1"/>
+          <p:nvPr/>
+        </p:nvSpPr>
+        <p:spPr>
+          <a:xfrm>
+            <a:off x="2860631" y="4000000"/>
+            <a:ext cx="15200000" cy="3500000"/>
+          </a:xfrm>
+          <a:prstGeom prst="rect">
+            <a:avLst/>
+          </a:prstGeom>
+          <a:noFill/>
+        </p:spPr>
+        <p:txBody>
+          <a:bodyPr rot="0" spcFirstLastPara="0" vertOverflow="overflow" horzOverflow="overflow" vert="horz" wrap="square" lIns="91440" tIns="45720" rIns="91440" bIns="45720" numCol="1" spcCol="0" rtlCol="0" fromWordArt="0" anchor="t" anchorCtr="0" forceAA="0" compatLnSpc="1">
+            <a:spAutoFit/>
+          </a:bodyPr>
+          <a:lstStyle/>
+          <a:p>
+            <a:pPr>
+              <a:lnSpc>
+                <a:spcPts val="4235"/>
+              </a:lnSpc>
+              <a:spcAft>
+                <a:spcPts val="1000"/>
+              </a:spcAft>
+            </a:pPr>
+            <a:r>
+              <a:rPr lang="en-US" sz="2600" b="1">
+                <a:solidFill>
+                  <a:srgbClr val="112D63"/>
+                </a:solidFill>
+                <a:latin typeface="Calibri" panose="020F0502020204030204"/>
+              </a:rPr>
+              <a:t>What's in scope, and what isn't:</a:t>
+            </a:r>
+          </a:p>
+          <a:p>
+            <a:pPr>
+              <a:spcAft>
+                <a:spcPts val="1000"/>
+              </a:spcAft>
+            </a:pPr>
+            <a:r>
+              <a:rPr lang="en-US" sz="2300" b="0" i="0">
+                <a:solidFill>
+                  <a:srgbClr val="3F3F3F"/>
+                </a:solidFill>
+                <a:latin typeface="Calibri" panose="020F0502020204030204"/>
+                <a:ea typeface="Calibri" panose="020F0502020204030204"/>
+                <a:cs typeface="Calibri" panose="020F0502020204030204"/>
+              </a:rPr>
+              <a:t>This project covers the Global Warming dataset (1900-2023): 100,000 records across 195 countries and 26 indicators, including temperature anomaly, CO2 emissions, population, forest area and renewable energy usage.</a:t>
+            </a:r>
+            <a:endParaRPr lang="en-US" sz="3000">
+              <a:ea typeface="Calibri" panose="020F0502020204030204"/>
+              <a:cs typeface="Calibri" panose="020F0502020204030204"/>
+            </a:endParaRPr>
+          </a:p>
+          <a:p>
+            <a:pPr>
+              <a:spcAft>
+                <a:spcPts val="1000"/>
+              </a:spcAft>
+            </a:pPr>
+            <a:r>
+              <a:rPr lang="en-US" sz="2300" b="0" i="0">
+                <a:solidFill>
+                  <a:srgbClr val="3F3F3F"/>
+                </a:solidFill>
+                <a:latin typeface="Calibri" panose="020F0502020204030204"/>
+                <a:ea typeface="Calibri" panose="020F0502020204030204"/>
+                <a:cs typeface="Calibri" panose="020F0502020204030204"/>
+              </a:rPr>
+              <a:t>The scope includes data cleaning, exploratory data analysis, and visualization, specifically building an animated heatmap of temperature anomalies over time. It does not include predictive modeling; the focus is on understanding and visually communicating what has already happened to the climate over the last century.</a:t>
+            </a:r>
+            <a:endParaRPr lang="en-US" sz="3000">
+              <a:ea typeface="Calibri" panose="020F0502020204030204"/>
+              <a:cs typeface="Calibri" panose="020F0502020204030204"/>
+            </a:endParaRPr>
+          </a:p>
+        </p:txBody>
+      </p:sp>
+      <p:sp>
+        <p:nvSpPr>
+          <p:cNvPr id="8" name="Rounded Rectangle 7"/>
+          <p:cNvSpPr/>
+          <p:nvPr/>
+        </p:nvSpPr>
+        <p:spPr>
+          <a:xfrm>
+            <a:off x="2860631" y="6900000"/>
+            <a:ext cx="4333333" cy="1500000"/>
+          </a:xfrm>
+          <a:prstGeom prst="roundRect">
+            <a:avLst>
+              <a:gd name="adj" fmla="val 8000"/>
+            </a:avLst>
+          </a:prstGeom>
+          <a:solidFill>
+            <a:srgbClr val="F4F8FD"/>
+          </a:solidFill>
+          <a:ln w="12700">
+            <a:solidFill>
+              <a:srgbClr val="E1E8F2"/>
+            </a:solidFill>
+          </a:ln>
+          <a:effectLst/>
+        </p:spPr>
+        <p:style>
+          <a:lnRef idx="1">
+            <a:schemeClr val="accent1"/>
+          </a:lnRef>
+          <a:fillRef idx="3">
+            <a:schemeClr val="accent1"/>
+          </a:fillRef>
+          <a:effectRef idx="2">
+            <a:schemeClr val="accent1"/>
+          </a:effectRef>
+          <a:fontRef idx="minor">
+            <a:schemeClr val="lt1"/>
+          </a:fontRef>
+        </p:style>
+        <p:txBody>
+          <a:bodyPr wrap="square" lIns="60000" tIns="120000" rIns="60000" rtlCol="0" anchor="ctr"/>
+          <a:lstStyle/>
+          <a:p>
+            <a:pPr algn="ctr"/>
+            <a:r>
+              <a:rPr sz="3000" b="1">
+                <a:solidFill>
+                  <a:srgbClr val="112D63"/>
+                </a:solidFill>
+                <a:latin typeface="Calibri" panose="020F0502020204030204"/>
+              </a:rPr>
+              <a:t>100,000</a:t>
+            </a:r>
+          </a:p>
+          <a:p>
+            <a:pPr algn="ctr"/>
+            <a:r>
+              <a:rPr sz="1400" b="0">
+                <a:solidFill>
+                  <a:srgbClr val="5A6472"/>
+                </a:solidFill>
+                <a:latin typeface="Calibri" panose="020F0502020204030204"/>
+              </a:rPr>
+              <a:t>Records</a:t>
+            </a:r>
+          </a:p>
+        </p:txBody>
+      </p:sp>
+      <p:sp>
+        <p:nvSpPr>
+          <p:cNvPr id="9" name="Rounded Rectangle 8"/>
+          <p:cNvSpPr/>
+          <p:nvPr/>
+        </p:nvSpPr>
+        <p:spPr>
+          <a:xfrm>
+            <a:off x="7443964" y="6900000"/>
+            <a:ext cx="4333333" cy="1500000"/>
+          </a:xfrm>
+          <a:prstGeom prst="roundRect">
+            <a:avLst>
+              <a:gd name="adj" fmla="val 8000"/>
+            </a:avLst>
+          </a:prstGeom>
+          <a:solidFill>
+            <a:srgbClr val="F4F8FD"/>
+          </a:solidFill>
+          <a:ln w="12700">
+            <a:solidFill>
+              <a:srgbClr val="E1E8F2"/>
+            </a:solidFill>
+          </a:ln>
+          <a:effectLst/>
+        </p:spPr>
+        <p:style>
+          <a:lnRef idx="1">
+            <a:schemeClr val="accent1"/>
+          </a:lnRef>
+          <a:fillRef idx="3">
+            <a:schemeClr val="accent1"/>
+          </a:fillRef>
+          <a:effectRef idx="2">
+            <a:schemeClr val="accent1"/>
+          </a:effectRef>
+          <a:fontRef idx="minor">
+            <a:schemeClr val="lt1"/>
+          </a:fontRef>
+        </p:style>
+        <p:txBody>
+          <a:bodyPr wrap="square" lIns="60000" tIns="120000" rIns="60000" rtlCol="0" anchor="ctr"/>
+          <a:lstStyle/>
+          <a:p>
+            <a:pPr algn="ctr"/>
+            <a:r>
+              <a:rPr sz="3000" b="1">
+                <a:solidFill>
+                  <a:srgbClr val="112D63"/>
+                </a:solidFill>
+                <a:latin typeface="Calibri" panose="020F0502020204030204"/>
+              </a:rPr>
+              <a:t>195</a:t>
+            </a:r>
+          </a:p>
+          <a:p>
+            <a:pPr algn="ctr"/>
+            <a:r>
+              <a:rPr sz="1400" b="0">
+                <a:solidFill>
+                  <a:srgbClr val="5A6472"/>
+                </a:solidFill>
+                <a:latin typeface="Calibri" panose="020F0502020204030204"/>
+              </a:rPr>
+              <a:t>Countries</a:t>
+            </a:r>
+          </a:p>
+        </p:txBody>
+      </p:sp>
+      <p:sp>
+        <p:nvSpPr>
+          <p:cNvPr id="10" name="Rounded Rectangle 9"/>
+          <p:cNvSpPr/>
+          <p:nvPr/>
+        </p:nvSpPr>
+        <p:spPr>
+          <a:xfrm>
+            <a:off x="12027297" y="6900000"/>
+            <a:ext cx="4333333" cy="1500000"/>
+          </a:xfrm>
+          <a:prstGeom prst="roundRect">
+            <a:avLst>
+              <a:gd name="adj" fmla="val 8000"/>
+            </a:avLst>
+          </a:prstGeom>
+          <a:solidFill>
+            <a:srgbClr val="F4F8FD"/>
+          </a:solidFill>
+          <a:ln w="12700">
+            <a:solidFill>
+              <a:srgbClr val="E1E8F2"/>
+            </a:solidFill>
+          </a:ln>
+          <a:effectLst/>
+        </p:spPr>
+        <p:style>
+          <a:lnRef idx="1">
+            <a:schemeClr val="accent1"/>
+          </a:lnRef>
+          <a:fillRef idx="3">
+            <a:schemeClr val="accent1"/>
+          </a:fillRef>
+          <a:effectRef idx="2">
+            <a:schemeClr val="accent1"/>
+          </a:effectRef>
+          <a:fontRef idx="minor">
+            <a:schemeClr val="lt1"/>
+          </a:fontRef>
+        </p:style>
+        <p:txBody>
+          <a:bodyPr wrap="square" lIns="60000" tIns="120000" rIns="60000" rtlCol="0" anchor="ctr"/>
+          <a:lstStyle/>
+          <a:p>
+            <a:pPr algn="ctr"/>
+            <a:r>
+              <a:rPr sz="3000" b="1">
+                <a:solidFill>
+                  <a:srgbClr val="112D63"/>
+                </a:solidFill>
+                <a:latin typeface="Calibri" panose="020F0502020204030204"/>
+              </a:rPr>
+              <a:t>26</a:t>
+            </a:r>
+          </a:p>
+          <a:p>
+            <a:pPr algn="ctr"/>
+            <a:r>
+              <a:rPr sz="1400" b="0">
+                <a:solidFill>
+                  <a:srgbClr val="5A6472"/>
+                </a:solidFill>
+                <a:latin typeface="Calibri" panose="020F0502020204030204"/>
+              </a:rPr>
+              <a:t>Indicators tracked</a:t>
+            </a:r>
+          </a:p>
+        </p:txBody>
+      </p:sp>
+    </p:spTree>
+  </p:cSld>
+  <p:clrMapOvr>
+    <a:masterClrMapping/>
+  </p:clrMapOvr>
+</p:sld>
+</file>
+
+<file path=ppt/slides/slide5.xml><?xml version="1.0" encoding="utf-8"?>
+<p:sld xmlns:a="http://schemas.openxmlformats.org/drawingml/2006/main" xmlns:r="http://schemas.openxmlformats.org/officeDocument/2006/relationships" xmlns:p="http://schemas.openxmlformats.org/presentationml/2006/main">
+  <p:cSld>
+    <p:bg>
+      <p:bgPr>
+        <a:solidFill>
+          <a:srgbClr val="F5FFFF"/>
+        </a:solidFill>
+        <a:effectLst/>
+      </p:bgPr>
+    </p:bg>
+    <p:spTree>
+      <p:nvGrpSpPr>
+        <p:cNvPr id="1" name=""/>
+        <p:cNvGrpSpPr/>
+        <p:nvPr/>
+      </p:nvGrpSpPr>
+      <p:grpSpPr>
+        <a:xfrm>
+          <a:off x="0" y="0"/>
+          <a:ext cx="0" cy="0"/>
+          <a:chOff x="0" y="0"/>
+          <a:chExt cx="0" cy="0"/>
+        </a:xfrm>
+      </p:grpSpPr>
+      <p:grpSp>
+        <p:nvGrpSpPr>
+          <p:cNvPr id="2" name="Group 2"/>
+          <p:cNvGrpSpPr/>
+          <p:nvPr/>
+        </p:nvGrpSpPr>
+        <p:grpSpPr>
+          <a:xfrm>
+            <a:off x="0" y="576841"/>
+            <a:ext cx="18288000" cy="2058570"/>
+            <a:chOff x="0" y="0"/>
+            <a:chExt cx="3738189" cy="420785"/>
+          </a:xfrm>
+        </p:grpSpPr>
+        <p:sp>
+          <p:nvSpPr>
+            <p:cNvPr id="3" name="Freeform 3"/>
+            <p:cNvSpPr/>
+            <p:nvPr/>
+          </p:nvSpPr>
+          <p:spPr>
+            <a:xfrm>
+              <a:off x="0" y="0"/>
+              <a:ext cx="3738189" cy="420785"/>
+            </a:xfrm>
+            <a:custGeom>
+              <a:avLst/>
+              <a:gdLst/>
+              <a:ahLst/>
+              <a:cxnLst/>
+              <a:rect l="l" t="t" r="r" b="b"/>
+              <a:pathLst>
+                <a:path w="3738189" h="420785">
+                  <a:moveTo>
+                    <a:pt x="3534989" y="0"/>
+                  </a:moveTo>
+                  <a:lnTo>
+                    <a:pt x="0" y="0"/>
+                  </a:lnTo>
+                  <a:lnTo>
+                    <a:pt x="0" y="420785"/>
+                  </a:lnTo>
+                  <a:lnTo>
+                    <a:pt x="3534989" y="420785"/>
+                  </a:lnTo>
+                  <a:lnTo>
+                    <a:pt x="3738189" y="210393"/>
+                  </a:lnTo>
+                  <a:lnTo>
+                    <a:pt x="3534989" y="0"/>
+                  </a:lnTo>
+                  <a:close/>
+                </a:path>
+              </a:pathLst>
+            </a:custGeom>
+            <a:solidFill>
+              <a:srgbClr val="112D63"/>
+            </a:solidFill>
+            <a:ln w="19050" cap="sq">
+              <a:solidFill>
+                <a:srgbClr val="112D63"/>
+              </a:solidFill>
+              <a:prstDash val="solid"/>
+              <a:miter/>
+            </a:ln>
+          </p:spPr>
+          <p:txBody>
+            <a:bodyPr/>
+            <a:lstStyle/>
+            <a:p>
+              <a:endParaRPr lang="en-IN"/>
+            </a:p>
+          </p:txBody>
+        </p:sp>
+        <p:sp>
+          <p:nvSpPr>
+            <p:cNvPr id="4" name="TextBox 4"/>
+            <p:cNvSpPr txBox="1"/>
+            <p:nvPr/>
+          </p:nvSpPr>
+          <p:spPr>
+            <a:xfrm>
+              <a:off x="0" y="-66675"/>
+              <a:ext cx="3623889" cy="487460"/>
+            </a:xfrm>
+            <a:prstGeom prst="rect">
+              <a:avLst/>
+            </a:prstGeom>
+          </p:spPr>
+          <p:txBody>
+            <a:bodyPr lIns="50800" tIns="50800" rIns="50800" bIns="50800" rtlCol="0" anchor="ctr"/>
+            <a:lstStyle/>
+            <a:p>
+              <a:pPr algn="ctr">
+                <a:lnSpc>
+                  <a:spcPts val="2800"/>
+                </a:lnSpc>
+              </a:pPr>
+              <a:endParaRPr/>
+            </a:p>
+          </p:txBody>
+        </p:sp>
+      </p:grpSp>
+      <p:sp>
+        <p:nvSpPr>
+          <p:cNvPr id="9" name="Rounded Rectangle 8"/>
+          <p:cNvSpPr/>
+          <p:nvPr/>
+        </p:nvSpPr>
+        <p:spPr>
+          <a:xfrm>
+            <a:off x="150000" y="2750000"/>
+            <a:ext cx="17988000" cy="6950000"/>
+          </a:xfrm>
+          <a:prstGeom prst="roundRect">
+            <a:avLst>
+              <a:gd name="adj" fmla="val 3500"/>
+            </a:avLst>
+          </a:prstGeom>
+          <a:solidFill>
+            <a:srgbClr val="FBFDFF"/>
+          </a:solidFill>
+          <a:ln w="12700">
+            <a:solidFill>
+              <a:srgbClr val="E1E8F2"/>
+            </a:solidFill>
+          </a:ln>
+          <a:effectLst/>
+        </p:spPr>
+        <p:style>
+          <a:lnRef idx="1">
+            <a:schemeClr val="accent1"/>
+          </a:lnRef>
+          <a:fillRef idx="3">
+            <a:schemeClr val="accent1"/>
+          </a:fillRef>
+          <a:effectRef idx="2">
+            <a:schemeClr val="accent1"/>
+          </a:effectRef>
+          <a:fontRef idx="minor">
+            <a:schemeClr val="lt1"/>
+          </a:fontRef>
+        </p:style>
+        <p:txBody>
+          <a:bodyPr rtlCol="0" anchor="ctr"/>
+          <a:lstStyle/>
+          <a:p>
+            <a:pPr algn="ctr"/>
+            <a:endParaRPr/>
+          </a:p>
+        </p:txBody>
+      </p:sp>
+      <p:sp>
+        <p:nvSpPr>
+          <p:cNvPr id="5" name="TextBox 5"/>
+          <p:cNvSpPr txBox="1"/>
+          <p:nvPr/>
+        </p:nvSpPr>
+        <p:spPr>
+          <a:xfrm>
+            <a:off x="4422448" y="923093"/>
+            <a:ext cx="8840169" cy="1185092"/>
+          </a:xfrm>
+          <a:prstGeom prst="rect">
+            <a:avLst/>
+          </a:prstGeom>
+        </p:spPr>
+        <p:txBody>
+          <a:bodyPr lIns="0" tIns="0" rIns="0" bIns="0" rtlCol="0" anchor="t">
+            <a:spAutoFit/>
+          </a:bodyPr>
+          <a:lstStyle/>
+          <a:p>
+            <a:pPr algn="ctr">
+              <a:lnSpc>
+                <a:spcPts val="9230"/>
+              </a:lnSpc>
+              <a:spcBef>
+                <a:spcPct val="0"/>
+              </a:spcBef>
+            </a:pPr>
+            <a:r>
+              <a:rPr lang="en-US" sz="4000" b="1">
+                <a:solidFill>
+                  <a:srgbClr val="FFFFFF"/>
+                </a:solidFill>
+                <a:latin typeface="Poppins Bold" panose="00000800000000000000"/>
+                <a:ea typeface="Poppins Bold" panose="00000800000000000000"/>
+                <a:cs typeface="Poppins Bold" panose="00000800000000000000"/>
+                <a:sym typeface="Poppins Bold" panose="00000800000000000000"/>
+              </a:rPr>
+              <a:t>Dataset Description</a:t>
+            </a:r>
+          </a:p>
+        </p:txBody>
+      </p:sp>
+      <p:sp>
+        <p:nvSpPr>
+          <p:cNvPr id="6" name="TextBox 6"/>
+          <p:cNvSpPr txBox="1"/>
+          <p:nvPr/>
+        </p:nvSpPr>
+        <p:spPr>
+          <a:xfrm>
+            <a:off x="2406709" y="3231254"/>
+            <a:ext cx="15200000" cy="3744230"/>
+          </a:xfrm>
+          <a:prstGeom prst="rect">
+            <a:avLst/>
+          </a:prstGeom>
+        </p:spPr>
+        <p:txBody>
+          <a:bodyPr lIns="0" tIns="0" rIns="0" bIns="0" rtlCol="0" anchor="t">
+            <a:spAutoFit/>
+          </a:bodyPr>
+          <a:lstStyle/>
+          <a:p>
+            <a:pPr>
+              <a:lnSpc>
+                <a:spcPts val="4235"/>
+              </a:lnSpc>
+              <a:spcAft>
+                <a:spcPts val="1000"/>
+              </a:spcAft>
+            </a:pPr>
+            <a:r>
               <a:rPr lang="en-US" sz="2600" b="1" i="0">
                 <a:solidFill>
                   <a:srgbClr val="112D63"/>
@@ -9644,7 +10094,7 @@
                 <a:ea typeface="+mn-lt"/>
                 <a:cs typeface="Poppins Italics" panose="00000500000000000000"/>
               </a:rPr>
-              <a:t>Here is our workflow so far, covering Weeks 1 through 4:</a:t>
+              <a:t>Here are the key details of our dataset:</a:t>
             </a:r>
             <a:endParaRPr lang="en-US"/>
           </a:p>
@@ -9672,14 +10122,14 @@
                 <a:cs typeface="Poppins Italics" panose="00000500000000000000"/>
                 <a:sym typeface="Poppins Italics" panose="00000500000000000000"/>
               </a:rPr>
-              <a:t>In Week 1, we selected the Global Warming dataset and set up our GitHub repository.</a:t>
+              <a:t>The dataset is a structured CSV file from Kaggle: Global Warming Dataset, 195 Countries (1900-2023).</a:t>
             </a:r>
             <a:endParaRPr lang="en-US" sz="3000" i="1">
               <a:solidFill>
                 <a:srgbClr val="545454"/>
               </a:solidFill>
               <a:latin typeface="Poppins Italics" panose="00000500000000000000"/>
-              <a:ea typeface="+mn-lt"/>
+              <a:ea typeface="Calibri" panose="020F0502020204030204"/>
               <a:cs typeface="Poppins Italics" panose="00000500000000000000"/>
             </a:endParaRPr>
           </a:p>
@@ -9705,15 +10155,16 @@
                 <a:latin typeface="Calibri" panose="020F0502020204030204"/>
                 <a:ea typeface="+mn-lt"/>
                 <a:cs typeface="Poppins Italics" panose="00000500000000000000"/>
+                <a:sym typeface="Poppins Italics" panose="00000500000000000000"/>
               </a:rPr>
-              <a:t>In Week 2, we explored the raw dataset's structure, checked column types, and put together a "first impression" report.</a:t>
+              <a:t>The variable we study most closely throughout the project is Temperature_Anomaly.</a:t>
             </a:r>
             <a:endParaRPr lang="en-US" sz="3000" i="1">
               <a:solidFill>
                 <a:srgbClr val="545454"/>
               </a:solidFill>
               <a:latin typeface="Poppins Italics" panose="00000500000000000000"/>
-              <a:ea typeface="Poppins Italics" panose="00000500000000000000"/>
+              <a:ea typeface="+mn-lt"/>
               <a:cs typeface="Poppins Italics" panose="00000500000000000000"/>
             </a:endParaRPr>
           </a:p>
@@ -9732,6 +10183,745 @@
               <a:buChar char="•"/>
             </a:pPr>
             <a:r>
+              <a:rPr sz="2200" b="0" i="0">
+                <a:solidFill>
+                  <a:srgbClr val="3F3F3F"/>
+                </a:solidFill>
+                <a:latin typeface="Calibri" panose="020F0502020204030204"/>
+              </a:rPr>
+              <a:t>The data is structured and almost entirely numeric, with Country as the only categorical field.</a:t>
+            </a:r>
+            <a:endParaRPr lang="en-US" sz="3000" i="1">
+              <a:solidFill>
+                <a:srgbClr val="545454"/>
+              </a:solidFill>
+              <a:latin typeface="Poppins Italics" panose="00000500000000000000"/>
+              <a:ea typeface="+mn-lt"/>
+              <a:cs typeface="Poppins Italics" panose="00000500000000000000"/>
+            </a:endParaRPr>
+          </a:p>
+          <a:p>
+            <a:pPr algn="l">
+              <a:lnSpc>
+                <a:spcPts val="4235"/>
+              </a:lnSpc>
+              <a:spcAft>
+                <a:spcPts val="1000"/>
+              </a:spcAft>
+            </a:pPr>
+            <a:endParaRPr lang="en-US" sz="3025" i="1">
+              <a:solidFill>
+                <a:srgbClr val="545454"/>
+              </a:solidFill>
+              <a:latin typeface="Poppins Italics" panose="00000500000000000000"/>
+              <a:ea typeface="Poppins Italics" panose="00000500000000000000"/>
+              <a:cs typeface="Poppins Italics" panose="00000500000000000000"/>
+              <a:sym typeface="Poppins Italics" panose="00000500000000000000"/>
+            </a:endParaRPr>
+          </a:p>
+        </p:txBody>
+      </p:sp>
+      <p:sp>
+        <p:nvSpPr>
+          <p:cNvPr id="8" name="Oval 7"/>
+          <p:cNvSpPr/>
+          <p:nvPr/>
+        </p:nvSpPr>
+        <p:spPr>
+          <a:xfrm>
+            <a:off x="745662" y="3482682"/>
+            <a:ext cx="1249424" cy="1249424"/>
+          </a:xfrm>
+          <a:prstGeom prst="ellipse">
+            <a:avLst/>
+          </a:prstGeom>
+          <a:solidFill>
+            <a:srgbClr val="FCE7DC"/>
+          </a:solidFill>
+          <a:ln>
+            <a:noFill/>
+          </a:ln>
+          <a:effectLst/>
+        </p:spPr>
+        <p:style>
+          <a:lnRef idx="1">
+            <a:schemeClr val="accent1"/>
+          </a:lnRef>
+          <a:fillRef idx="3">
+            <a:schemeClr val="accent1"/>
+          </a:fillRef>
+          <a:effectRef idx="2">
+            <a:schemeClr val="accent1"/>
+          </a:effectRef>
+          <a:fontRef idx="minor">
+            <a:schemeClr val="lt1"/>
+          </a:fontRef>
+        </p:style>
+        <p:txBody>
+          <a:bodyPr rtlCol="0" anchor="ctr"/>
+          <a:lstStyle/>
+          <a:p>
+            <a:pPr algn="ctr"/>
+            <a:endParaRPr/>
+          </a:p>
+        </p:txBody>
+      </p:sp>
+      <p:sp>
+        <p:nvSpPr>
+          <p:cNvPr id="7" name="Freeform 7"/>
+          <p:cNvSpPr/>
+          <p:nvPr/>
+        </p:nvSpPr>
+        <p:spPr>
+          <a:xfrm>
+            <a:off x="589484" y="3326504"/>
+            <a:ext cx="1561780" cy="1561780"/>
+          </a:xfrm>
+          <a:custGeom>
+            <a:avLst/>
+            <a:gdLst/>
+            <a:ahLst/>
+            <a:cxnLst/>
+            <a:rect l="l" t="t" r="r" b="b"/>
+            <a:pathLst>
+              <a:path w="1561780" h="1561780">
+                <a:moveTo>
+                  <a:pt x="0" y="0"/>
+                </a:moveTo>
+                <a:lnTo>
+                  <a:pt x="1561781" y="0"/>
+                </a:lnTo>
+                <a:lnTo>
+                  <a:pt x="1561781" y="1561780"/>
+                </a:lnTo>
+                <a:lnTo>
+                  <a:pt x="0" y="1561780"/>
+                </a:lnTo>
+                <a:lnTo>
+                  <a:pt x="0" y="0"/>
+                </a:lnTo>
+                <a:close/>
+              </a:path>
+            </a:pathLst>
+          </a:custGeom>
+          <a:blipFill>
+            <a:blip>
+              <a:extLst>
+                <a:ext uri="{96DAC541-7B7A-43D3-8B79-37D633B846F1}">
+                  <asvg:svgBlip xmlns:asvg="http://schemas.microsoft.com/office/drawing/2016/SVG/main" r:embed="rId2"/>
+                </a:ext>
+              </a:extLst>
+            </a:blip>
+            <a:stretch>
+              <a:fillRect/>
+            </a:stretch>
+          </a:blipFill>
+        </p:spPr>
+        <p:txBody>
+          <a:bodyPr/>
+          <a:lstStyle/>
+          <a:p>
+            <a:endParaRPr lang="en-IN"/>
+          </a:p>
+        </p:txBody>
+      </p:sp>
+      <p:sp>
+        <p:nvSpPr>
+          <p:cNvPr id="10" name="Rounded Rectangle 9"/>
+          <p:cNvSpPr/>
+          <p:nvPr/>
+        </p:nvSpPr>
+        <p:spPr>
+          <a:xfrm>
+            <a:off x="2406709" y="6750000"/>
+            <a:ext cx="3612500" cy="1500000"/>
+          </a:xfrm>
+          <a:prstGeom prst="roundRect">
+            <a:avLst>
+              <a:gd name="adj" fmla="val 8000"/>
+            </a:avLst>
+          </a:prstGeom>
+          <a:solidFill>
+            <a:srgbClr val="F4F8FD"/>
+          </a:solidFill>
+          <a:ln w="12700">
+            <a:solidFill>
+              <a:srgbClr val="E1E8F2"/>
+            </a:solidFill>
+          </a:ln>
+          <a:effectLst/>
+        </p:spPr>
+        <p:style>
+          <a:lnRef idx="1">
+            <a:schemeClr val="accent1"/>
+          </a:lnRef>
+          <a:fillRef idx="3">
+            <a:schemeClr val="accent1"/>
+          </a:fillRef>
+          <a:effectRef idx="2">
+            <a:schemeClr val="accent1"/>
+          </a:effectRef>
+          <a:fontRef idx="minor">
+            <a:schemeClr val="lt1"/>
+          </a:fontRef>
+        </p:style>
+        <p:txBody>
+          <a:bodyPr wrap="square" lIns="60000" tIns="120000" rIns="60000" rtlCol="0" anchor="ctr"/>
+          <a:lstStyle/>
+          <a:p>
+            <a:pPr algn="ctr"/>
+            <a:r>
+              <a:rPr sz="3000" b="1">
+                <a:solidFill>
+                  <a:srgbClr val="112D63"/>
+                </a:solidFill>
+                <a:latin typeface="Calibri" panose="020F0502020204030204"/>
+              </a:rPr>
+              <a:t>100,000</a:t>
+            </a:r>
+          </a:p>
+          <a:p>
+            <a:pPr algn="ctr"/>
+            <a:r>
+              <a:rPr sz="1400" b="0">
+                <a:solidFill>
+                  <a:srgbClr val="5A6472"/>
+                </a:solidFill>
+                <a:latin typeface="Calibri" panose="020F0502020204030204"/>
+              </a:rPr>
+              <a:t>Records</a:t>
+            </a:r>
+          </a:p>
+        </p:txBody>
+      </p:sp>
+      <p:sp>
+        <p:nvSpPr>
+          <p:cNvPr id="11" name="Rounded Rectangle 10"/>
+          <p:cNvSpPr/>
+          <p:nvPr/>
+        </p:nvSpPr>
+        <p:spPr>
+          <a:xfrm>
+            <a:off x="6269209" y="6750000"/>
+            <a:ext cx="3612500" cy="1500000"/>
+          </a:xfrm>
+          <a:prstGeom prst="roundRect">
+            <a:avLst>
+              <a:gd name="adj" fmla="val 8000"/>
+            </a:avLst>
+          </a:prstGeom>
+          <a:solidFill>
+            <a:srgbClr val="F4F8FD"/>
+          </a:solidFill>
+          <a:ln w="12700">
+            <a:solidFill>
+              <a:srgbClr val="E1E8F2"/>
+            </a:solidFill>
+          </a:ln>
+          <a:effectLst/>
+        </p:spPr>
+        <p:style>
+          <a:lnRef idx="1">
+            <a:schemeClr val="accent1"/>
+          </a:lnRef>
+          <a:fillRef idx="3">
+            <a:schemeClr val="accent1"/>
+          </a:fillRef>
+          <a:effectRef idx="2">
+            <a:schemeClr val="accent1"/>
+          </a:effectRef>
+          <a:fontRef idx="minor">
+            <a:schemeClr val="lt1"/>
+          </a:fontRef>
+        </p:style>
+        <p:txBody>
+          <a:bodyPr wrap="square" lIns="60000" tIns="120000" rIns="60000" rtlCol="0" anchor="ctr"/>
+          <a:lstStyle/>
+          <a:p>
+            <a:pPr algn="ctr"/>
+            <a:r>
+              <a:rPr sz="3000" b="1">
+                <a:solidFill>
+                  <a:srgbClr val="112D63"/>
+                </a:solidFill>
+                <a:latin typeface="Calibri" panose="020F0502020204030204"/>
+              </a:rPr>
+              <a:t>195</a:t>
+            </a:r>
+          </a:p>
+          <a:p>
+            <a:pPr algn="ctr"/>
+            <a:r>
+              <a:rPr sz="1400" b="0">
+                <a:solidFill>
+                  <a:srgbClr val="5A6472"/>
+                </a:solidFill>
+                <a:latin typeface="Calibri" panose="020F0502020204030204"/>
+              </a:rPr>
+              <a:t>Countries</a:t>
+            </a:r>
+          </a:p>
+        </p:txBody>
+      </p:sp>
+      <p:sp>
+        <p:nvSpPr>
+          <p:cNvPr id="12" name="Rounded Rectangle 11"/>
+          <p:cNvSpPr/>
+          <p:nvPr/>
+        </p:nvSpPr>
+        <p:spPr>
+          <a:xfrm>
+            <a:off x="10131709" y="6750000"/>
+            <a:ext cx="3612500" cy="1500000"/>
+          </a:xfrm>
+          <a:prstGeom prst="roundRect">
+            <a:avLst>
+              <a:gd name="adj" fmla="val 8000"/>
+            </a:avLst>
+          </a:prstGeom>
+          <a:solidFill>
+            <a:srgbClr val="F4F8FD"/>
+          </a:solidFill>
+          <a:ln w="12700">
+            <a:solidFill>
+              <a:srgbClr val="E1E8F2"/>
+            </a:solidFill>
+          </a:ln>
+          <a:effectLst/>
+        </p:spPr>
+        <p:style>
+          <a:lnRef idx="1">
+            <a:schemeClr val="accent1"/>
+          </a:lnRef>
+          <a:fillRef idx="3">
+            <a:schemeClr val="accent1"/>
+          </a:fillRef>
+          <a:effectRef idx="2">
+            <a:schemeClr val="accent1"/>
+          </a:effectRef>
+          <a:fontRef idx="minor">
+            <a:schemeClr val="lt1"/>
+          </a:fontRef>
+        </p:style>
+        <p:txBody>
+          <a:bodyPr wrap="square" lIns="60000" tIns="120000" rIns="60000" rtlCol="0" anchor="ctr"/>
+          <a:lstStyle/>
+          <a:p>
+            <a:pPr algn="ctr"/>
+            <a:r>
+              <a:rPr sz="3000" b="1">
+                <a:solidFill>
+                  <a:srgbClr val="112D63"/>
+                </a:solidFill>
+                <a:latin typeface="Calibri" panose="020F0502020204030204"/>
+              </a:rPr>
+              <a:t>26</a:t>
+            </a:r>
+          </a:p>
+          <a:p>
+            <a:pPr algn="ctr"/>
+            <a:r>
+              <a:rPr sz="1400" b="0">
+                <a:solidFill>
+                  <a:srgbClr val="5A6472"/>
+                </a:solidFill>
+                <a:latin typeface="Calibri" panose="020F0502020204030204"/>
+              </a:rPr>
+              <a:t>Columns</a:t>
+            </a:r>
+          </a:p>
+        </p:txBody>
+      </p:sp>
+      <p:sp>
+        <p:nvSpPr>
+          <p:cNvPr id="13" name="Rounded Rectangle 12"/>
+          <p:cNvSpPr/>
+          <p:nvPr/>
+        </p:nvSpPr>
+        <p:spPr>
+          <a:xfrm>
+            <a:off x="13994209" y="6750000"/>
+            <a:ext cx="3612500" cy="1500000"/>
+          </a:xfrm>
+          <a:prstGeom prst="roundRect">
+            <a:avLst>
+              <a:gd name="adj" fmla="val 8000"/>
+            </a:avLst>
+          </a:prstGeom>
+          <a:solidFill>
+            <a:srgbClr val="F4F8FD"/>
+          </a:solidFill>
+          <a:ln w="12700">
+            <a:solidFill>
+              <a:srgbClr val="E1E8F2"/>
+            </a:solidFill>
+          </a:ln>
+          <a:effectLst/>
+        </p:spPr>
+        <p:style>
+          <a:lnRef idx="1">
+            <a:schemeClr val="accent1"/>
+          </a:lnRef>
+          <a:fillRef idx="3">
+            <a:schemeClr val="accent1"/>
+          </a:fillRef>
+          <a:effectRef idx="2">
+            <a:schemeClr val="accent1"/>
+          </a:effectRef>
+          <a:fontRef idx="minor">
+            <a:schemeClr val="lt1"/>
+          </a:fontRef>
+        </p:style>
+        <p:txBody>
+          <a:bodyPr wrap="square" lIns="60000" tIns="120000" rIns="60000" rtlCol="0" anchor="ctr"/>
+          <a:lstStyle/>
+          <a:p>
+            <a:pPr algn="ctr"/>
+            <a:r>
+              <a:rPr sz="3000" b="1">
+                <a:solidFill>
+                  <a:srgbClr val="112D63"/>
+                </a:solidFill>
+                <a:latin typeface="Calibri" panose="020F0502020204030204"/>
+              </a:rPr>
+              <a:t>1900–2023</a:t>
+            </a:r>
+          </a:p>
+          <a:p>
+            <a:pPr algn="ctr"/>
+            <a:r>
+              <a:rPr sz="1400" b="0">
+                <a:solidFill>
+                  <a:srgbClr val="5A6472"/>
+                </a:solidFill>
+                <a:latin typeface="Calibri" panose="020F0502020204030204"/>
+              </a:rPr>
+              <a:t>Years covered</a:t>
+            </a:r>
+          </a:p>
+        </p:txBody>
+      </p:sp>
+    </p:spTree>
+  </p:cSld>
+  <p:clrMapOvr>
+    <a:masterClrMapping/>
+  </p:clrMapOvr>
+</p:sld>
+</file>
+
+<file path=ppt/slides/slide6.xml><?xml version="1.0" encoding="utf-8"?>
+<p:sld xmlns:a="http://schemas.openxmlformats.org/drawingml/2006/main" xmlns:r="http://schemas.openxmlformats.org/officeDocument/2006/relationships" xmlns:p="http://schemas.openxmlformats.org/presentationml/2006/main">
+  <p:cSld>
+    <p:bg>
+      <p:bgPr>
+        <a:solidFill>
+          <a:srgbClr val="F5FFFF"/>
+        </a:solidFill>
+        <a:effectLst/>
+      </p:bgPr>
+    </p:bg>
+    <p:spTree>
+      <p:nvGrpSpPr>
+        <p:cNvPr id="1" name=""/>
+        <p:cNvGrpSpPr/>
+        <p:nvPr/>
+      </p:nvGrpSpPr>
+      <p:grpSpPr>
+        <a:xfrm>
+          <a:off x="0" y="0"/>
+          <a:ext cx="0" cy="0"/>
+          <a:chOff x="0" y="0"/>
+          <a:chExt cx="0" cy="0"/>
+        </a:xfrm>
+      </p:grpSpPr>
+      <p:grpSp>
+        <p:nvGrpSpPr>
+          <p:cNvPr id="2" name="Group 2"/>
+          <p:cNvGrpSpPr/>
+          <p:nvPr/>
+        </p:nvGrpSpPr>
+        <p:grpSpPr>
+          <a:xfrm>
+            <a:off x="0" y="576841"/>
+            <a:ext cx="18288000" cy="2058570"/>
+            <a:chOff x="0" y="0"/>
+            <a:chExt cx="3738189" cy="420785"/>
+          </a:xfrm>
+        </p:grpSpPr>
+        <p:sp>
+          <p:nvSpPr>
+            <p:cNvPr id="3" name="Freeform 3"/>
+            <p:cNvSpPr/>
+            <p:nvPr/>
+          </p:nvSpPr>
+          <p:spPr>
+            <a:xfrm>
+              <a:off x="0" y="0"/>
+              <a:ext cx="3738189" cy="420785"/>
+            </a:xfrm>
+            <a:custGeom>
+              <a:avLst/>
+              <a:gdLst/>
+              <a:ahLst/>
+              <a:cxnLst/>
+              <a:rect l="l" t="t" r="r" b="b"/>
+              <a:pathLst>
+                <a:path w="3738189" h="420785">
+                  <a:moveTo>
+                    <a:pt x="3534989" y="0"/>
+                  </a:moveTo>
+                  <a:lnTo>
+                    <a:pt x="0" y="0"/>
+                  </a:lnTo>
+                  <a:lnTo>
+                    <a:pt x="0" y="420785"/>
+                  </a:lnTo>
+                  <a:lnTo>
+                    <a:pt x="3534989" y="420785"/>
+                  </a:lnTo>
+                  <a:lnTo>
+                    <a:pt x="3738189" y="210393"/>
+                  </a:lnTo>
+                  <a:lnTo>
+                    <a:pt x="3534989" y="0"/>
+                  </a:lnTo>
+                  <a:close/>
+                </a:path>
+              </a:pathLst>
+            </a:custGeom>
+            <a:solidFill>
+              <a:srgbClr val="112D63"/>
+            </a:solidFill>
+            <a:ln w="19050" cap="sq">
+              <a:solidFill>
+                <a:srgbClr val="112D63"/>
+              </a:solidFill>
+              <a:prstDash val="solid"/>
+              <a:miter/>
+            </a:ln>
+          </p:spPr>
+          <p:txBody>
+            <a:bodyPr/>
+            <a:lstStyle/>
+            <a:p>
+              <a:endParaRPr lang="en-IN"/>
+            </a:p>
+          </p:txBody>
+        </p:sp>
+        <p:sp>
+          <p:nvSpPr>
+            <p:cNvPr id="4" name="TextBox 4"/>
+            <p:cNvSpPr txBox="1"/>
+            <p:nvPr/>
+          </p:nvSpPr>
+          <p:spPr>
+            <a:xfrm>
+              <a:off x="0" y="-66675"/>
+              <a:ext cx="3623889" cy="487460"/>
+            </a:xfrm>
+            <a:prstGeom prst="rect">
+              <a:avLst/>
+            </a:prstGeom>
+          </p:spPr>
+          <p:txBody>
+            <a:bodyPr lIns="50800" tIns="50800" rIns="50800" bIns="50800" rtlCol="0" anchor="ctr"/>
+            <a:lstStyle/>
+            <a:p>
+              <a:pPr algn="ctr">
+                <a:lnSpc>
+                  <a:spcPts val="2800"/>
+                </a:lnSpc>
+              </a:pPr>
+              <a:endParaRPr/>
+            </a:p>
+          </p:txBody>
+        </p:sp>
+      </p:grpSp>
+      <p:sp>
+        <p:nvSpPr>
+          <p:cNvPr id="9" name="Rounded Rectangle 8"/>
+          <p:cNvSpPr/>
+          <p:nvPr/>
+        </p:nvSpPr>
+        <p:spPr>
+          <a:xfrm>
+            <a:off x="150000" y="2750000"/>
+            <a:ext cx="17988000" cy="6950000"/>
+          </a:xfrm>
+          <a:prstGeom prst="roundRect">
+            <a:avLst>
+              <a:gd name="adj" fmla="val 3500"/>
+            </a:avLst>
+          </a:prstGeom>
+          <a:solidFill>
+            <a:srgbClr val="FBFDFF"/>
+          </a:solidFill>
+          <a:ln w="12700">
+            <a:solidFill>
+              <a:srgbClr val="E1E8F2"/>
+            </a:solidFill>
+          </a:ln>
+          <a:effectLst/>
+        </p:spPr>
+        <p:style>
+          <a:lnRef idx="1">
+            <a:schemeClr val="accent1"/>
+          </a:lnRef>
+          <a:fillRef idx="3">
+            <a:schemeClr val="accent1"/>
+          </a:fillRef>
+          <a:effectRef idx="2">
+            <a:schemeClr val="accent1"/>
+          </a:effectRef>
+          <a:fontRef idx="minor">
+            <a:schemeClr val="lt1"/>
+          </a:fontRef>
+        </p:style>
+        <p:txBody>
+          <a:bodyPr rtlCol="0" anchor="ctr"/>
+          <a:lstStyle/>
+          <a:p>
+            <a:pPr algn="ctr"/>
+            <a:endParaRPr/>
+          </a:p>
+        </p:txBody>
+      </p:sp>
+      <p:sp>
+        <p:nvSpPr>
+          <p:cNvPr id="5" name="TextBox 5"/>
+          <p:cNvSpPr txBox="1"/>
+          <p:nvPr/>
+        </p:nvSpPr>
+        <p:spPr>
+          <a:xfrm>
+            <a:off x="1054565" y="985640"/>
+            <a:ext cx="16178870" cy="1069521"/>
+          </a:xfrm>
+          <a:prstGeom prst="rect">
+            <a:avLst/>
+          </a:prstGeom>
+        </p:spPr>
+        <p:txBody>
+          <a:bodyPr lIns="0" tIns="0" rIns="0" bIns="0" rtlCol="0" anchor="t">
+            <a:spAutoFit/>
+          </a:bodyPr>
+          <a:lstStyle/>
+          <a:p>
+            <a:pPr algn="ctr">
+              <a:lnSpc>
+                <a:spcPts val="8250"/>
+              </a:lnSpc>
+              <a:spcBef>
+                <a:spcPct val="0"/>
+              </a:spcBef>
+            </a:pPr>
+            <a:r>
+              <a:rPr lang="en-US" sz="4000" b="1">
+                <a:solidFill>
+                  <a:srgbClr val="FFFFFF"/>
+                </a:solidFill>
+                <a:latin typeface="Poppins Bold" panose="00000800000000000000"/>
+                <a:ea typeface="Poppins Bold" panose="00000800000000000000"/>
+                <a:cs typeface="Poppins Bold" panose="00000800000000000000"/>
+                <a:sym typeface="Poppins Bold" panose="00000800000000000000"/>
+              </a:rPr>
+              <a:t>Methodology(Process / Workflow)</a:t>
+            </a:r>
+          </a:p>
+        </p:txBody>
+      </p:sp>
+      <p:sp>
+        <p:nvSpPr>
+          <p:cNvPr id="6" name="TextBox 6"/>
+          <p:cNvSpPr txBox="1"/>
+          <p:nvPr/>
+        </p:nvSpPr>
+        <p:spPr>
+          <a:xfrm>
+            <a:off x="2406709" y="3231254"/>
+            <a:ext cx="15200000" cy="3205621"/>
+          </a:xfrm>
+          <a:prstGeom prst="rect">
+            <a:avLst/>
+          </a:prstGeom>
+        </p:spPr>
+        <p:txBody>
+          <a:bodyPr wrap="square" lIns="0" tIns="0" rIns="0" bIns="0" rtlCol="0" anchor="t">
+            <a:spAutoFit/>
+          </a:bodyPr>
+          <a:lstStyle/>
+          <a:p>
+            <a:pPr>
+              <a:lnSpc>
+                <a:spcPts val="4235"/>
+              </a:lnSpc>
+              <a:spcAft>
+                <a:spcPts val="1000"/>
+              </a:spcAft>
+            </a:pPr>
+            <a:r>
+              <a:rPr lang="en-US" sz="2600" b="1" i="0">
+                <a:solidFill>
+                  <a:srgbClr val="112D63"/>
+                </a:solidFill>
+                <a:latin typeface="Calibri" panose="020F0502020204030204"/>
+                <a:ea typeface="+mn-lt"/>
+                <a:cs typeface="Poppins Italics" panose="00000500000000000000"/>
+              </a:rPr>
+              <a:t>Here is our workflow so far, covering Weeks 1 through 4:</a:t>
+            </a:r>
+            <a:endParaRPr lang="en-US"/>
+          </a:p>
+          <a:p>
+            <a:pPr marL="652780" lvl="1" indent="-326390">
+              <a:lnSpc>
+                <a:spcPts val="4235"/>
+              </a:lnSpc>
+              <a:spcAft>
+                <a:spcPts val="1000"/>
+              </a:spcAft>
+              <a:buClr>
+                <a:srgbClr val="E8622C"/>
+              </a:buClr>
+              <a:buFont typeface="Arial" panose="020B0604020202020204"/>
+              <a:buChar char="•"/>
+            </a:pPr>
+            <a:r>
+              <a:rPr lang="en-US" sz="2200" b="0" i="0">
+                <a:solidFill>
+                  <a:srgbClr val="3F3F3F"/>
+                </a:solidFill>
+                <a:latin typeface="Calibri" panose="020F0502020204030204"/>
+                <a:ea typeface="+mn-lt"/>
+                <a:cs typeface="Poppins Italics" panose="00000500000000000000"/>
+                <a:sym typeface="Poppins Italics" panose="00000500000000000000"/>
+              </a:rPr>
+              <a:t>In Week 1, we selected the Global Warming dataset and set up our GitHub repository.</a:t>
+            </a:r>
+            <a:endParaRPr lang="en-US" sz="3000" i="1">
+              <a:solidFill>
+                <a:srgbClr val="545454"/>
+              </a:solidFill>
+              <a:latin typeface="Poppins Italics" panose="00000500000000000000"/>
+              <a:ea typeface="+mn-lt"/>
+              <a:cs typeface="Poppins Italics" panose="00000500000000000000"/>
+            </a:endParaRPr>
+          </a:p>
+          <a:p>
+            <a:pPr marL="652780" lvl="1" indent="-326390">
+              <a:lnSpc>
+                <a:spcPts val="4235"/>
+              </a:lnSpc>
+              <a:spcAft>
+                <a:spcPts val="1000"/>
+              </a:spcAft>
+              <a:buClr>
+                <a:srgbClr val="E8622C"/>
+              </a:buClr>
+              <a:buFont typeface="Arial" panose="020B0604020202020204"/>
+              <a:buChar char="•"/>
+            </a:pPr>
+            <a:r>
               <a:rPr lang="en-US" sz="2200" b="0" i="0">
                 <a:solidFill>
                   <a:srgbClr val="3F3F3F"/>
@@ -9740,7 +10930,41 @@
                 <a:ea typeface="+mn-lt"/>
                 <a:cs typeface="Poppins Italics" panose="00000500000000000000"/>
               </a:rPr>
-              <a:t>In Week 3, we cleaned the data with median imputation on six columns, removed duplicate rows, and removed outliers flagged by both the IQR and Z-score methods.</a:t>
+              <a:t>In Week 2, we explored the raw dataset's structure, checked column types, and put together a "first impression" report.</a:t>
+            </a:r>
+            <a:endParaRPr lang="en-US" sz="3000" i="1">
+              <a:solidFill>
+                <a:srgbClr val="545454"/>
+              </a:solidFill>
+              <a:latin typeface="Poppins Italics" panose="00000500000000000000"/>
+              <a:ea typeface="Poppins Italics" panose="00000500000000000000"/>
+              <a:cs typeface="Poppins Italics" panose="00000500000000000000"/>
+            </a:endParaRPr>
+          </a:p>
+          <a:p>
+            <a:pPr marL="652780" lvl="1" indent="-326390">
+              <a:lnSpc>
+                <a:spcPts val="4235"/>
+              </a:lnSpc>
+              <a:spcAft>
+                <a:spcPts val="1000"/>
+              </a:spcAft>
+              <a:buClr>
+                <a:srgbClr val="E8622C"/>
+              </a:buClr>
+              <a:buFont typeface="Arial" panose="020B0604020202020204"/>
+              <a:buChar char="•"/>
+            </a:pPr>
+            <a:r>
+              <a:rPr lang="en-US" sz="2200" b="0" i="0">
+                <a:solidFill>
+                  <a:srgbClr val="3F3F3F"/>
+                </a:solidFill>
+                <a:latin typeface="Calibri" panose="020F0502020204030204"/>
+                <a:ea typeface="+mn-lt"/>
+                <a:cs typeface="Poppins Italics" panose="00000500000000000000"/>
+              </a:rPr>
+              <a:t>In Week 3, we cleaned the data with median imputation on six columns and checked for duplicate rows and outliers using both the IQR and Z-score methods; none were found.</a:t>
             </a:r>
             <a:endParaRPr lang="en-US" sz="3000" i="1">
               <a:solidFill>
@@ -10503,7 +11727,7 @@
                           </a:solidFill>
                           <a:latin typeface="Calibri" panose="020F0502020204030204"/>
                         </a:rPr>
-                        <a:t>Outlier column, cleaned via Z-score</a:t>
+                        <a:t>No outliers (IQR and Z-score)</a:t>
                       </a:r>
                     </a:p>
                   </a:txBody>
@@ -10659,7 +11883,7 @@
                 </a:solidFill>
                 <a:latin typeface="Calibri" panose="020F0502020204030204"/>
               </a:rPr>
-              <a:t>150 values (0.15%) exceeded this bound and were removed as outliers.</a:t>
+              <a:t>No value exceeded this bound, so 0 outliers were found.</a:t>
             </a:r>
           </a:p>
         </p:txBody>
@@ -10912,7 +12136,7 @@
                 <a:cs typeface="Poppins Italics" panose="00000500000000000000"/>
                 <a:sym typeface="Poppins Italics" panose="00000500000000000000"/>
               </a:rPr>
-              <a:t>We filled missing values in six columns using median imputation, removed duplicate rows, and validated the Year (1900-2023) and Country (195 unique) fields. We also detected outliers using both the IQR and Z-score methods and removed rows with a Z-score above 3, cutting outliers from 949 to 59. This resulted in a fully clean dataset, Global_Warming_Fully_Cleaned.csv, with zero missing values, zero duplicates and no extreme outliers.</a:t>
+              <a:t>We filled missing values in six columns using median imputation, checked for duplicate rows (0 found), and validated the Year (1900-2023) and Country (195 unique) fields. We also tested for outliers using both the IQR and Z-score (threshold 3) methods; neither flagged any value, so no rows were removed. This resulted in a clean dataset of 100,000 records, Global_Warming_Fully_Cleaned.csv, with zero missing values and zero duplicates.</a:t>
             </a:r>
           </a:p>
           <a:p>
@@ -11427,7 +12651,7 @@
                 <a:cs typeface="Poppins Italics" panose="00000500000000000000"/>
                 <a:sym typeface="Poppins Italics" panose="00000500000000000000"/>
               </a:rPr>
-              <a:t>Our key insight: some countries and recent decades show clearly higher average anomalies than others.</a:t>
+              <a:t>Our key insight: average anomalies stay close to zero across countries and decades, and the variables show almost no correlation.</a:t>
             </a:r>
           </a:p>
           <a:p>

</xml_diff>